<commit_message>
Fix PDF radar chart overlapping text & enable real Gmail SMTP email delivery
</commit_message>
<xml_diff>
--- a/Review_III_Presentation.pptx
+++ b/Review_III_Presentation.pptx
@@ -5,22 +5,22 @@
     <p:sldMasterId id="2147483648" r:id="rId1"/>
   </p:sldMasterIdLst>
   <p:sldIdLst>
-    <p:sldId id="256" r:id="rId7"/>
-    <p:sldId id="257" r:id="rId8"/>
-    <p:sldId id="258" r:id="rId9"/>
-    <p:sldId id="259" r:id="rId10"/>
-    <p:sldId id="260" r:id="rId11"/>
-    <p:sldId id="261" r:id="rId12"/>
-    <p:sldId id="262" r:id="rId13"/>
-    <p:sldId id="263" r:id="rId14"/>
-    <p:sldId id="264" r:id="rId15"/>
-    <p:sldId id="265" r:id="rId16"/>
-    <p:sldId id="266" r:id="rId17"/>
-    <p:sldId id="267" r:id="rId18"/>
-    <p:sldId id="268" r:id="rId19"/>
-    <p:sldId id="269" r:id="rId20"/>
+    <p:sldId id="256" r:id="rId2"/>
+    <p:sldId id="257" r:id="rId3"/>
+    <p:sldId id="258" r:id="rId4"/>
+    <p:sldId id="259" r:id="rId5"/>
+    <p:sldId id="260" r:id="rId6"/>
+    <p:sldId id="261" r:id="rId7"/>
+    <p:sldId id="262" r:id="rId8"/>
+    <p:sldId id="263" r:id="rId9"/>
+    <p:sldId id="264" r:id="rId10"/>
+    <p:sldId id="265" r:id="rId11"/>
+    <p:sldId id="266" r:id="rId12"/>
+    <p:sldId id="267" r:id="rId13"/>
+    <p:sldId id="268" r:id="rId14"/>
+    <p:sldId id="269" r:id="rId15"/>
   </p:sldIdLst>
-  <p:sldSz cx="12191695" cy="6858000" type="screen4x3"/>
+  <p:sldSz cx="12192000" cy="6858000"/>
   <p:notesSz cx="6858000" cy="9144000"/>
   <p:defaultTextStyle>
     <a:defPPr>
@@ -117,6 +117,22 @@
       </a:defRPr>
     </a:lvl9pPr>
   </p:defaultTextStyle>
+  <p:extLst>
+    <p:ext uri="{EFAFB233-063F-42B5-8137-9DF3F51BA10A}">
+      <p15:sldGuideLst xmlns:p15="http://schemas.microsoft.com/office/powerpoint/2012/main">
+        <p15:guide id="1" orient="horz" pos="2160">
+          <p15:clr>
+            <a:srgbClr val="A4A3A4"/>
+          </p15:clr>
+        </p15:guide>
+        <p15:guide id="2" pos="2880">
+          <p15:clr>
+            <a:srgbClr val="A4A3A4"/>
+          </p15:clr>
+        </p15:guide>
+      </p15:sldGuideLst>
+    </p:ext>
+  </p:extLst>
 </p:presentation>
 </file>
 
@@ -158,10 +174,9 @@
           <a:lstStyle/>
           <a:p>
             <a:r>
-              <a:rPr lang="en-US" smtClean="0"/>
+              <a:rPr lang="en-US"/>
               <a:t>Click to edit Master title style</a:t>
             </a:r>
-            <a:endParaRPr lang="en-US"/>
           </a:p>
         </p:txBody>
       </p:sp>
@@ -277,10 +292,9 @@
           </a:lstStyle>
           <a:p>
             <a:r>
-              <a:rPr lang="en-US" smtClean="0"/>
+              <a:rPr lang="en-US"/>
               <a:t>Click to edit Master subtitle style</a:t>
             </a:r>
-            <a:endParaRPr lang="en-US"/>
           </a:p>
         </p:txBody>
       </p:sp>
@@ -301,7 +315,7 @@
           <a:p>
             <a:fld id="{5BCAD085-E8A6-8845-BD4E-CB4CCA059FC4}" type="datetimeFigureOut">
               <a:rPr lang="en-US" smtClean="0"/>
-              <a:t>1/27/13</a:t>
+              <a:t>9/15/2026</a:t>
             </a:fld>
             <a:endParaRPr lang="en-US"/>
           </a:p>
@@ -395,10 +409,9 @@
           <a:lstStyle/>
           <a:p>
             <a:r>
-              <a:rPr lang="en-US" smtClean="0"/>
+              <a:rPr lang="en-US"/>
               <a:t>Click to edit Master title style</a:t>
             </a:r>
-            <a:endParaRPr lang="en-US"/>
           </a:p>
         </p:txBody>
       </p:sp>
@@ -419,38 +432,37 @@
           <a:p>
             <a:pPr lvl="0"/>
             <a:r>
-              <a:rPr lang="en-US" smtClean="0"/>
+              <a:rPr lang="en-US"/>
               <a:t>Click to edit Master text styles</a:t>
             </a:r>
           </a:p>
           <a:p>
             <a:pPr lvl="1"/>
             <a:r>
-              <a:rPr lang="en-US" smtClean="0"/>
+              <a:rPr lang="en-US"/>
               <a:t>Second level</a:t>
             </a:r>
           </a:p>
           <a:p>
             <a:pPr lvl="2"/>
             <a:r>
-              <a:rPr lang="en-US" smtClean="0"/>
+              <a:rPr lang="en-US"/>
               <a:t>Third level</a:t>
             </a:r>
           </a:p>
           <a:p>
             <a:pPr lvl="3"/>
             <a:r>
-              <a:rPr lang="en-US" smtClean="0"/>
+              <a:rPr lang="en-US"/>
               <a:t>Fourth level</a:t>
             </a:r>
           </a:p>
           <a:p>
             <a:pPr lvl="4"/>
             <a:r>
-              <a:rPr lang="en-US" smtClean="0"/>
+              <a:rPr lang="en-US"/>
               <a:t>Fifth level</a:t>
             </a:r>
-            <a:endParaRPr lang="en-US"/>
           </a:p>
         </p:txBody>
       </p:sp>
@@ -471,7 +483,7 @@
           <a:p>
             <a:fld id="{5BCAD085-E8A6-8845-BD4E-CB4CCA059FC4}" type="datetimeFigureOut">
               <a:rPr lang="en-US" smtClean="0"/>
-              <a:t>1/27/13</a:t>
+              <a:t>9/15/2026</a:t>
             </a:fld>
             <a:endParaRPr lang="en-US"/>
           </a:p>
@@ -570,10 +582,9 @@
           <a:lstStyle/>
           <a:p>
             <a:r>
-              <a:rPr lang="en-US" smtClean="0"/>
+              <a:rPr lang="en-US"/>
               <a:t>Click to edit Master title style</a:t>
             </a:r>
-            <a:endParaRPr lang="en-US"/>
           </a:p>
         </p:txBody>
       </p:sp>
@@ -599,38 +610,37 @@
           <a:p>
             <a:pPr lvl="0"/>
             <a:r>
-              <a:rPr lang="en-US" smtClean="0"/>
+              <a:rPr lang="en-US"/>
               <a:t>Click to edit Master text styles</a:t>
             </a:r>
           </a:p>
           <a:p>
             <a:pPr lvl="1"/>
             <a:r>
-              <a:rPr lang="en-US" smtClean="0"/>
+              <a:rPr lang="en-US"/>
               <a:t>Second level</a:t>
             </a:r>
           </a:p>
           <a:p>
             <a:pPr lvl="2"/>
             <a:r>
-              <a:rPr lang="en-US" smtClean="0"/>
+              <a:rPr lang="en-US"/>
               <a:t>Third level</a:t>
             </a:r>
           </a:p>
           <a:p>
             <a:pPr lvl="3"/>
             <a:r>
-              <a:rPr lang="en-US" smtClean="0"/>
+              <a:rPr lang="en-US"/>
               <a:t>Fourth level</a:t>
             </a:r>
           </a:p>
           <a:p>
             <a:pPr lvl="4"/>
             <a:r>
-              <a:rPr lang="en-US" smtClean="0"/>
+              <a:rPr lang="en-US"/>
               <a:t>Fifth level</a:t>
             </a:r>
-            <a:endParaRPr lang="en-US"/>
           </a:p>
         </p:txBody>
       </p:sp>
@@ -651,7 +661,7 @@
           <a:p>
             <a:fld id="{5BCAD085-E8A6-8845-BD4E-CB4CCA059FC4}" type="datetimeFigureOut">
               <a:rPr lang="en-US" smtClean="0"/>
-              <a:t>1/27/13</a:t>
+              <a:t>9/15/2026</a:t>
             </a:fld>
             <a:endParaRPr lang="en-US"/>
           </a:p>
@@ -745,10 +755,9 @@
           <a:lstStyle/>
           <a:p>
             <a:r>
-              <a:rPr lang="en-US" smtClean="0"/>
+              <a:rPr lang="en-US"/>
               <a:t>Click to edit Master title style</a:t>
             </a:r>
-            <a:endParaRPr lang="en-US"/>
           </a:p>
         </p:txBody>
       </p:sp>
@@ -769,38 +778,37 @@
           <a:p>
             <a:pPr lvl="0"/>
             <a:r>
-              <a:rPr lang="en-US" smtClean="0"/>
+              <a:rPr lang="en-US"/>
               <a:t>Click to edit Master text styles</a:t>
             </a:r>
           </a:p>
           <a:p>
             <a:pPr lvl="1"/>
             <a:r>
-              <a:rPr lang="en-US" smtClean="0"/>
+              <a:rPr lang="en-US"/>
               <a:t>Second level</a:t>
             </a:r>
           </a:p>
           <a:p>
             <a:pPr lvl="2"/>
             <a:r>
-              <a:rPr lang="en-US" smtClean="0"/>
+              <a:rPr lang="en-US"/>
               <a:t>Third level</a:t>
             </a:r>
           </a:p>
           <a:p>
             <a:pPr lvl="3"/>
             <a:r>
-              <a:rPr lang="en-US" smtClean="0"/>
+              <a:rPr lang="en-US"/>
               <a:t>Fourth level</a:t>
             </a:r>
           </a:p>
           <a:p>
             <a:pPr lvl="4"/>
             <a:r>
-              <a:rPr lang="en-US" smtClean="0"/>
+              <a:rPr lang="en-US"/>
               <a:t>Fifth level</a:t>
             </a:r>
-            <a:endParaRPr lang="en-US"/>
           </a:p>
         </p:txBody>
       </p:sp>
@@ -821,7 +829,7 @@
           <a:p>
             <a:fld id="{5BCAD085-E8A6-8845-BD4E-CB4CCA059FC4}" type="datetimeFigureOut">
               <a:rPr lang="en-US" smtClean="0"/>
-              <a:t>1/27/13</a:t>
+              <a:t>9/15/2026</a:t>
             </a:fld>
             <a:endParaRPr lang="en-US"/>
           </a:p>
@@ -924,10 +932,9 @@
           </a:lstStyle>
           <a:p>
             <a:r>
-              <a:rPr lang="en-US" smtClean="0"/>
+              <a:rPr lang="en-US"/>
               <a:t>Click to edit Master title style</a:t>
             </a:r>
-            <a:endParaRPr lang="en-US"/>
           </a:p>
         </p:txBody>
       </p:sp>
@@ -1044,7 +1051,7 @@
           <a:p>
             <a:pPr lvl="0"/>
             <a:r>
-              <a:rPr lang="en-US" smtClean="0"/>
+              <a:rPr lang="en-US"/>
               <a:t>Click to edit Master text styles</a:t>
             </a:r>
           </a:p>
@@ -1067,7 +1074,7 @@
           <a:p>
             <a:fld id="{5BCAD085-E8A6-8845-BD4E-CB4CCA059FC4}" type="datetimeFigureOut">
               <a:rPr lang="en-US" smtClean="0"/>
-              <a:t>1/27/13</a:t>
+              <a:t>9/15/2026</a:t>
             </a:fld>
             <a:endParaRPr lang="en-US"/>
           </a:p>
@@ -1161,10 +1168,9 @@
           <a:lstStyle/>
           <a:p>
             <a:r>
-              <a:rPr lang="en-US" smtClean="0"/>
+              <a:rPr lang="en-US"/>
               <a:t>Click to edit Master title style</a:t>
             </a:r>
-            <a:endParaRPr lang="en-US"/>
           </a:p>
         </p:txBody>
       </p:sp>
@@ -1218,38 +1224,37 @@
           <a:p>
             <a:pPr lvl="0"/>
             <a:r>
-              <a:rPr lang="en-US" smtClean="0"/>
+              <a:rPr lang="en-US"/>
               <a:t>Click to edit Master text styles</a:t>
             </a:r>
           </a:p>
           <a:p>
             <a:pPr lvl="1"/>
             <a:r>
-              <a:rPr lang="en-US" smtClean="0"/>
+              <a:rPr lang="en-US"/>
               <a:t>Second level</a:t>
             </a:r>
           </a:p>
           <a:p>
             <a:pPr lvl="2"/>
             <a:r>
-              <a:rPr lang="en-US" smtClean="0"/>
+              <a:rPr lang="en-US"/>
               <a:t>Third level</a:t>
             </a:r>
           </a:p>
           <a:p>
             <a:pPr lvl="3"/>
             <a:r>
-              <a:rPr lang="en-US" smtClean="0"/>
+              <a:rPr lang="en-US"/>
               <a:t>Fourth level</a:t>
             </a:r>
           </a:p>
           <a:p>
             <a:pPr lvl="4"/>
             <a:r>
-              <a:rPr lang="en-US" smtClean="0"/>
+              <a:rPr lang="en-US"/>
               <a:t>Fifth level</a:t>
             </a:r>
-            <a:endParaRPr lang="en-US"/>
           </a:p>
         </p:txBody>
       </p:sp>
@@ -1303,38 +1308,37 @@
           <a:p>
             <a:pPr lvl="0"/>
             <a:r>
-              <a:rPr lang="en-US" smtClean="0"/>
+              <a:rPr lang="en-US"/>
               <a:t>Click to edit Master text styles</a:t>
             </a:r>
           </a:p>
           <a:p>
             <a:pPr lvl="1"/>
             <a:r>
-              <a:rPr lang="en-US" smtClean="0"/>
+              <a:rPr lang="en-US"/>
               <a:t>Second level</a:t>
             </a:r>
           </a:p>
           <a:p>
             <a:pPr lvl="2"/>
             <a:r>
-              <a:rPr lang="en-US" smtClean="0"/>
+              <a:rPr lang="en-US"/>
               <a:t>Third level</a:t>
             </a:r>
           </a:p>
           <a:p>
             <a:pPr lvl="3"/>
             <a:r>
-              <a:rPr lang="en-US" smtClean="0"/>
+              <a:rPr lang="en-US"/>
               <a:t>Fourth level</a:t>
             </a:r>
           </a:p>
           <a:p>
             <a:pPr lvl="4"/>
             <a:r>
-              <a:rPr lang="en-US" smtClean="0"/>
+              <a:rPr lang="en-US"/>
               <a:t>Fifth level</a:t>
             </a:r>
-            <a:endParaRPr lang="en-US"/>
           </a:p>
         </p:txBody>
       </p:sp>
@@ -1355,7 +1359,7 @@
           <a:p>
             <a:fld id="{5BCAD085-E8A6-8845-BD4E-CB4CCA059FC4}" type="datetimeFigureOut">
               <a:rPr lang="en-US" smtClean="0"/>
-              <a:t>1/27/13</a:t>
+              <a:t>9/15/2026</a:t>
             </a:fld>
             <a:endParaRPr lang="en-US"/>
           </a:p>
@@ -1453,10 +1457,9 @@
           </a:lstStyle>
           <a:p>
             <a:r>
-              <a:rPr lang="en-US" smtClean="0"/>
+              <a:rPr lang="en-US"/>
               <a:t>Click to edit Master title style</a:t>
             </a:r>
-            <a:endParaRPr lang="en-US"/>
           </a:p>
         </p:txBody>
       </p:sp>
@@ -1519,7 +1522,7 @@
           <a:p>
             <a:pPr lvl="0"/>
             <a:r>
-              <a:rPr lang="en-US" smtClean="0"/>
+              <a:rPr lang="en-US"/>
               <a:t>Click to edit Master text styles</a:t>
             </a:r>
           </a:p>
@@ -1575,38 +1578,37 @@
           <a:p>
             <a:pPr lvl="0"/>
             <a:r>
-              <a:rPr lang="en-US" smtClean="0"/>
+              <a:rPr lang="en-US"/>
               <a:t>Click to edit Master text styles</a:t>
             </a:r>
           </a:p>
           <a:p>
             <a:pPr lvl="1"/>
             <a:r>
-              <a:rPr lang="en-US" smtClean="0"/>
+              <a:rPr lang="en-US"/>
               <a:t>Second level</a:t>
             </a:r>
           </a:p>
           <a:p>
             <a:pPr lvl="2"/>
             <a:r>
-              <a:rPr lang="en-US" smtClean="0"/>
+              <a:rPr lang="en-US"/>
               <a:t>Third level</a:t>
             </a:r>
           </a:p>
           <a:p>
             <a:pPr lvl="3"/>
             <a:r>
-              <a:rPr lang="en-US" smtClean="0"/>
+              <a:rPr lang="en-US"/>
               <a:t>Fourth level</a:t>
             </a:r>
           </a:p>
           <a:p>
             <a:pPr lvl="4"/>
             <a:r>
-              <a:rPr lang="en-US" smtClean="0"/>
+              <a:rPr lang="en-US"/>
               <a:t>Fifth level</a:t>
             </a:r>
-            <a:endParaRPr lang="en-US"/>
           </a:p>
         </p:txBody>
       </p:sp>
@@ -1669,7 +1671,7 @@
           <a:p>
             <a:pPr lvl="0"/>
             <a:r>
-              <a:rPr lang="en-US" smtClean="0"/>
+              <a:rPr lang="en-US"/>
               <a:t>Click to edit Master text styles</a:t>
             </a:r>
           </a:p>
@@ -1725,38 +1727,37 @@
           <a:p>
             <a:pPr lvl="0"/>
             <a:r>
-              <a:rPr lang="en-US" smtClean="0"/>
+              <a:rPr lang="en-US"/>
               <a:t>Click to edit Master text styles</a:t>
             </a:r>
           </a:p>
           <a:p>
             <a:pPr lvl="1"/>
             <a:r>
-              <a:rPr lang="en-US" smtClean="0"/>
+              <a:rPr lang="en-US"/>
               <a:t>Second level</a:t>
             </a:r>
           </a:p>
           <a:p>
             <a:pPr lvl="2"/>
             <a:r>
-              <a:rPr lang="en-US" smtClean="0"/>
+              <a:rPr lang="en-US"/>
               <a:t>Third level</a:t>
             </a:r>
           </a:p>
           <a:p>
             <a:pPr lvl="3"/>
             <a:r>
-              <a:rPr lang="en-US" smtClean="0"/>
+              <a:rPr lang="en-US"/>
               <a:t>Fourth level</a:t>
             </a:r>
           </a:p>
           <a:p>
             <a:pPr lvl="4"/>
             <a:r>
-              <a:rPr lang="en-US" smtClean="0"/>
+              <a:rPr lang="en-US"/>
               <a:t>Fifth level</a:t>
             </a:r>
-            <a:endParaRPr lang="en-US"/>
           </a:p>
         </p:txBody>
       </p:sp>
@@ -1777,7 +1778,7 @@
           <a:p>
             <a:fld id="{5BCAD085-E8A6-8845-BD4E-CB4CCA059FC4}" type="datetimeFigureOut">
               <a:rPr lang="en-US" smtClean="0"/>
-              <a:t>1/27/13</a:t>
+              <a:t>9/15/2026</a:t>
             </a:fld>
             <a:endParaRPr lang="en-US"/>
           </a:p>
@@ -1871,10 +1872,9 @@
           <a:lstStyle/>
           <a:p>
             <a:r>
-              <a:rPr lang="en-US" smtClean="0"/>
+              <a:rPr lang="en-US"/>
               <a:t>Click to edit Master title style</a:t>
             </a:r>
-            <a:endParaRPr lang="en-US"/>
           </a:p>
         </p:txBody>
       </p:sp>
@@ -1895,7 +1895,7 @@
           <a:p>
             <a:fld id="{5BCAD085-E8A6-8845-BD4E-CB4CCA059FC4}" type="datetimeFigureOut">
               <a:rPr lang="en-US" smtClean="0"/>
-              <a:t>1/27/13</a:t>
+              <a:t>9/15/2026</a:t>
             </a:fld>
             <a:endParaRPr lang="en-US"/>
           </a:p>
@@ -1990,7 +1990,7 @@
           <a:p>
             <a:fld id="{5BCAD085-E8A6-8845-BD4E-CB4CCA059FC4}" type="datetimeFigureOut">
               <a:rPr lang="en-US" smtClean="0"/>
-              <a:t>1/27/13</a:t>
+              <a:t>9/15/2026</a:t>
             </a:fld>
             <a:endParaRPr lang="en-US"/>
           </a:p>
@@ -2093,10 +2093,9 @@
           </a:lstStyle>
           <a:p>
             <a:r>
-              <a:rPr lang="en-US" smtClean="0"/>
+              <a:rPr lang="en-US"/>
               <a:t>Click to edit Master title style</a:t>
             </a:r>
-            <a:endParaRPr lang="en-US"/>
           </a:p>
         </p:txBody>
       </p:sp>
@@ -2150,38 +2149,37 @@
           <a:p>
             <a:pPr lvl="0"/>
             <a:r>
-              <a:rPr lang="en-US" smtClean="0"/>
+              <a:rPr lang="en-US"/>
               <a:t>Click to edit Master text styles</a:t>
             </a:r>
           </a:p>
           <a:p>
             <a:pPr lvl="1"/>
             <a:r>
-              <a:rPr lang="en-US" smtClean="0"/>
+              <a:rPr lang="en-US"/>
               <a:t>Second level</a:t>
             </a:r>
           </a:p>
           <a:p>
             <a:pPr lvl="2"/>
             <a:r>
-              <a:rPr lang="en-US" smtClean="0"/>
+              <a:rPr lang="en-US"/>
               <a:t>Third level</a:t>
             </a:r>
           </a:p>
           <a:p>
             <a:pPr lvl="3"/>
             <a:r>
-              <a:rPr lang="en-US" smtClean="0"/>
+              <a:rPr lang="en-US"/>
               <a:t>Fourth level</a:t>
             </a:r>
           </a:p>
           <a:p>
             <a:pPr lvl="4"/>
             <a:r>
-              <a:rPr lang="en-US" smtClean="0"/>
+              <a:rPr lang="en-US"/>
               <a:t>Fifth level</a:t>
             </a:r>
-            <a:endParaRPr lang="en-US"/>
           </a:p>
         </p:txBody>
       </p:sp>
@@ -2244,7 +2242,7 @@
           <a:p>
             <a:pPr lvl="0"/>
             <a:r>
-              <a:rPr lang="en-US" smtClean="0"/>
+              <a:rPr lang="en-US"/>
               <a:t>Click to edit Master text styles</a:t>
             </a:r>
           </a:p>
@@ -2267,7 +2265,7 @@
           <a:p>
             <a:fld id="{5BCAD085-E8A6-8845-BD4E-CB4CCA059FC4}" type="datetimeFigureOut">
               <a:rPr lang="en-US" smtClean="0"/>
-              <a:t>1/27/13</a:t>
+              <a:t>9/15/2026</a:t>
             </a:fld>
             <a:endParaRPr lang="en-US"/>
           </a:p>
@@ -2370,10 +2368,9 @@
           </a:lstStyle>
           <a:p>
             <a:r>
-              <a:rPr lang="en-US" smtClean="0"/>
+              <a:rPr lang="en-US"/>
               <a:t>Click to edit Master title style</a:t>
             </a:r>
-            <a:endParaRPr lang="en-US"/>
           </a:p>
         </p:txBody>
       </p:sp>
@@ -2497,7 +2494,7 @@
           <a:p>
             <a:pPr lvl="0"/>
             <a:r>
-              <a:rPr lang="en-US" smtClean="0"/>
+              <a:rPr lang="en-US"/>
               <a:t>Click to edit Master text styles</a:t>
             </a:r>
           </a:p>
@@ -2520,7 +2517,7 @@
           <a:p>
             <a:fld id="{5BCAD085-E8A6-8845-BD4E-CB4CCA059FC4}" type="datetimeFigureOut">
               <a:rPr lang="en-US" smtClean="0"/>
-              <a:t>1/27/13</a:t>
+              <a:t>9/15/2026</a:t>
             </a:fld>
             <a:endParaRPr lang="en-US"/>
           </a:p>
@@ -2629,10 +2626,9 @@
           <a:lstStyle/>
           <a:p>
             <a:r>
-              <a:rPr lang="en-US" smtClean="0"/>
+              <a:rPr lang="en-US"/>
               <a:t>Click to edit Master title style</a:t>
             </a:r>
-            <a:endParaRPr lang="en-US"/>
           </a:p>
         </p:txBody>
       </p:sp>
@@ -2663,38 +2659,37 @@
           <a:p>
             <a:pPr lvl="0"/>
             <a:r>
-              <a:rPr lang="en-US" smtClean="0"/>
+              <a:rPr lang="en-US"/>
               <a:t>Click to edit Master text styles</a:t>
             </a:r>
           </a:p>
           <a:p>
             <a:pPr lvl="1"/>
             <a:r>
-              <a:rPr lang="en-US" smtClean="0"/>
+              <a:rPr lang="en-US"/>
               <a:t>Second level</a:t>
             </a:r>
           </a:p>
           <a:p>
             <a:pPr lvl="2"/>
             <a:r>
-              <a:rPr lang="en-US" smtClean="0"/>
+              <a:rPr lang="en-US"/>
               <a:t>Third level</a:t>
             </a:r>
           </a:p>
           <a:p>
             <a:pPr lvl="3"/>
             <a:r>
-              <a:rPr lang="en-US" smtClean="0"/>
+              <a:rPr lang="en-US"/>
               <a:t>Fourth level</a:t>
             </a:r>
           </a:p>
           <a:p>
             <a:pPr lvl="4"/>
             <a:r>
-              <a:rPr lang="en-US" smtClean="0"/>
+              <a:rPr lang="en-US"/>
               <a:t>Fifth level</a:t>
             </a:r>
-            <a:endParaRPr lang="en-US"/>
           </a:p>
         </p:txBody>
       </p:sp>
@@ -2733,7 +2728,7 @@
           <a:p>
             <a:fld id="{5BCAD085-E8A6-8845-BD4E-CB4CCA059FC4}" type="datetimeFigureOut">
               <a:rPr lang="en-US" smtClean="0"/>
-              <a:t>1/27/13</a:t>
+              <a:t>9/15/2026</a:t>
             </a:fld>
             <a:endParaRPr lang="en-US"/>
           </a:p>
@@ -3092,7 +3087,7 @@
 </file>
 
 <file path=ppt/slides/slide1.xml><?xml version="1.0" encoding="utf-8"?>
-<p:sld xmlns:a="http://schemas.openxmlformats.org/drawingml/2006/main" xmlns:p="http://schemas.openxmlformats.org/presentationml/2006/main" xmlns:r="http://schemas.openxmlformats.org/officeDocument/2006/relationships">
+<p:sld xmlns:a="http://schemas.openxmlformats.org/drawingml/2006/main" xmlns:r="http://schemas.openxmlformats.org/officeDocument/2006/relationships" xmlns:p="http://schemas.openxmlformats.org/presentationml/2006/main">
   <p:cSld>
     <p:spTree>
       <p:nvGrpSpPr>
@@ -3100,7 +3095,14 @@
         <p:cNvGrpSpPr/>
         <p:nvPr/>
       </p:nvGrpSpPr>
-      <p:grpSpPr/>
+      <p:grpSpPr>
+        <a:xfrm>
+          <a:off x="0" y="0"/>
+          <a:ext cx="0" cy="0"/>
+          <a:chOff x="0" y="0"/>
+          <a:chExt cx="0" cy="0"/>
+        </a:xfrm>
+      </p:grpSpPr>
       <p:sp>
         <p:nvSpPr>
           <p:cNvPr id="2" name="Rectangle 1"/>
@@ -3141,6 +3143,7 @@
           <a:lstStyle/>
           <a:p>
             <a:pPr algn="ctr"/>
+            <a:endParaRPr/>
           </a:p>
         </p:txBody>
       </p:sp>
@@ -3152,8 +3155,8 @@
         </p:nvSpPr>
         <p:spPr>
           <a:xfrm>
-            <a:off x="914400" y="914400"/>
-            <a:ext cx="10362895" cy="365760"/>
+            <a:off x="924025" y="914400"/>
+            <a:ext cx="4168129" cy="261610"/>
           </a:xfrm>
           <a:prstGeom prst="rect">
             <a:avLst/>
@@ -3175,7 +3178,8 @@
               </a:defRPr>
             </a:pPr>
             <a:r>
-              <a:t>REVIEW III – PANEL REVIEW | WORKING IMPLEMENTATION PHASE (20 MARKS)</a:t>
+              <a:rPr dirty="0"/>
+              <a:t>REVIEW III – PANEL REVIEW | WORKING IMPLEMENTATION PHASE</a:t>
             </a:r>
           </a:p>
         </p:txBody>
@@ -3298,6 +3302,7 @@
           <a:lstStyle/>
           <a:p>
             <a:pPr algn="ctr"/>
+            <a:endParaRPr/>
           </a:p>
         </p:txBody>
       </p:sp>
@@ -3310,7 +3315,7 @@
         <p:spPr>
           <a:xfrm>
             <a:off x="1188720" y="3657600"/>
-            <a:ext cx="4754880" cy="2103120"/>
+            <a:ext cx="4754880" cy="954107"/>
           </a:xfrm>
           <a:prstGeom prst="rect">
             <a:avLst/>
@@ -3324,13 +3329,14 @@
           <a:lstStyle/>
           <a:p>
             <a:pPr>
-              <a:defRPr b="1" sz="1000">
+              <a:defRPr sz="1000" b="1">
                 <a:solidFill>
                   <a:srgbClr val="D9C5B2"/>
                 </a:solidFill>
               </a:defRPr>
             </a:pPr>
             <a:r>
+              <a:rPr sz="1400" dirty="0"/>
               <a:t>PROJECT SUPERVISION &amp; INSTITUTION</a:t>
             </a:r>
           </a:p>
@@ -3339,7 +3345,7 @@
               <a:defRPr sz="1050"/>
             </a:pPr>
             <a:r>
-              <a:rPr b="1">
+              <a:rPr sz="1400" b="1" dirty="0">
                 <a:solidFill>
                   <a:srgbClr val="FFFFFF"/>
                 </a:solidFill>
@@ -3347,7 +3353,7 @@
               <a:t>Project Guide: </a:t>
             </a:r>
             <a:r>
-              <a:rPr>
+              <a:rPr sz="1400" dirty="0">
                 <a:solidFill>
                   <a:srgbClr val="DCDCDC"/>
                 </a:solidFill>
@@ -3360,7 +3366,7 @@
               <a:defRPr sz="1050"/>
             </a:pPr>
             <a:r>
-              <a:rPr b="1">
+              <a:rPr sz="1400" b="1" dirty="0">
                 <a:solidFill>
                   <a:srgbClr val="FFFFFF"/>
                 </a:solidFill>
@@ -3368,7 +3374,7 @@
               <a:t>Department: </a:t>
             </a:r>
             <a:r>
-              <a:rPr>
+              <a:rPr sz="1400" dirty="0">
                 <a:solidFill>
                   <a:srgbClr val="DCDCDC"/>
                 </a:solidFill>
@@ -3381,7 +3387,7 @@
               <a:defRPr sz="1050"/>
             </a:pPr>
             <a:r>
-              <a:rPr b="1">
+              <a:rPr sz="1400" b="1" dirty="0">
                 <a:solidFill>
                   <a:srgbClr val="FFFFFF"/>
                 </a:solidFill>
@@ -3389,7 +3395,7 @@
               <a:t>Domain: </a:t>
             </a:r>
             <a:r>
-              <a:rPr>
+              <a:rPr sz="1400" dirty="0">
                 <a:solidFill>
                   <a:srgbClr val="DCDCDC"/>
                 </a:solidFill>
@@ -3397,48 +3403,6 @@
               <a:t>Autonomous AI Agents, Financial NLP, &amp; RAG Systems</a:t>
             </a:r>
           </a:p>
-          <a:p>
-            <a:pPr>
-              <a:defRPr sz="1050"/>
-            </a:pPr>
-            <a:r>
-              <a:rPr b="1">
-                <a:solidFill>
-                  <a:srgbClr val="FFFFFF"/>
-                </a:solidFill>
-              </a:rPr>
-              <a:t>Milestone: </a:t>
-            </a:r>
-            <a:r>
-              <a:rPr>
-                <a:solidFill>
-                  <a:srgbClr val="DCDCDC"/>
-                </a:solidFill>
-              </a:rPr>
-              <a:t>Review III – Working Implementation &amp; Empirical Validation</a:t>
-            </a:r>
-          </a:p>
-          <a:p>
-            <a:pPr>
-              <a:defRPr sz="1050"/>
-            </a:pPr>
-            <a:r>
-              <a:rPr b="1">
-                <a:solidFill>
-                  <a:srgbClr val="FFFFFF"/>
-                </a:solidFill>
-              </a:rPr>
-              <a:t>Scope Completed: </a:t>
-            </a:r>
-            <a:r>
-              <a:rPr>
-                <a:solidFill>
-                  <a:srgbClr val="DCDCDC"/>
-                </a:solidFill>
-              </a:rPr>
-              <a:t>50%+ of Approved Capstone Specification</a:t>
-            </a:r>
-          </a:p>
         </p:txBody>
       </p:sp>
       <p:sp>
@@ -3450,7 +3414,7 @@
         <p:spPr>
           <a:xfrm>
             <a:off x="6217920" y="3657600"/>
-            <a:ext cx="4754880" cy="2103120"/>
+            <a:ext cx="4754880" cy="1384995"/>
           </a:xfrm>
           <a:prstGeom prst="rect">
             <a:avLst/>
@@ -3464,13 +3428,14 @@
           <a:lstStyle/>
           <a:p>
             <a:pPr>
-              <a:defRPr b="1" sz="1000">
+              <a:defRPr sz="1000" b="1">
                 <a:solidFill>
                   <a:srgbClr val="D9C5B2"/>
                 </a:solidFill>
               </a:defRPr>
             </a:pPr>
             <a:r>
+              <a:rPr sz="1400" dirty="0"/>
               <a:t>PROJECT TEAM MEMBERS</a:t>
             </a:r>
           </a:p>
@@ -3479,7 +3444,7 @@
               <a:defRPr sz="1050"/>
             </a:pPr>
             <a:r>
-              <a:rPr b="1">
+              <a:rPr sz="1400" b="1" dirty="0">
                 <a:solidFill>
                   <a:srgbClr val="FFFFFF"/>
                 </a:solidFill>
@@ -3487,20 +3452,33 @@
               <a:t>Sanjna S </a:t>
             </a:r>
             <a:r>
-              <a:rPr>
+              <a:rPr sz="1400" dirty="0">
                 <a:solidFill>
                   <a:srgbClr val="C8C8C8"/>
                 </a:solidFill>
               </a:rPr>
-              <a:t>(Multi-Agent Architecture &amp; LangGraph Pipeline)</a:t>
-            </a:r>
+              <a:t>(</a:t>
+            </a:r>
+            <a:r>
+              <a:rPr lang="en-IN" sz="1400" dirty="0">
+                <a:solidFill>
+                  <a:srgbClr val="C8C8C8"/>
+                </a:solidFill>
+              </a:rPr>
+              <a:t>23BCE1374)</a:t>
+            </a:r>
+            <a:endParaRPr sz="1400" dirty="0">
+              <a:solidFill>
+                <a:srgbClr val="C8C8C8"/>
+              </a:solidFill>
+            </a:endParaRPr>
           </a:p>
           <a:p>
             <a:pPr>
               <a:defRPr sz="1050"/>
             </a:pPr>
             <a:r>
-              <a:rPr b="1">
+              <a:rPr sz="1400" b="1" dirty="0">
                 <a:solidFill>
                   <a:srgbClr val="FFFFFF"/>
                 </a:solidFill>
@@ -3508,12 +3486,20 @@
               <a:t>Akshara </a:t>
             </a:r>
             <a:r>
-              <a:rPr>
+              <a:rPr sz="1400" dirty="0">
                 <a:solidFill>
                   <a:srgbClr val="C8C8C8"/>
                 </a:solidFill>
               </a:rPr>
-              <a:t>(Enterprise Guardrails, Security &amp; Fact Verification)</a:t>
+              <a:t>(</a:t>
+            </a:r>
+            <a:r>
+              <a:rPr lang="en-IN" sz="1400" dirty="0">
+                <a:solidFill>
+                  <a:srgbClr val="C8C8C8"/>
+                </a:solidFill>
+              </a:rPr>
+              <a:t>23BCE1325)</a:t>
             </a:r>
           </a:p>
           <a:p>
@@ -3521,7 +3507,7 @@
               <a:defRPr sz="1050"/>
             </a:pPr>
             <a:r>
-              <a:rPr b="1">
+              <a:rPr sz="1400" b="1" dirty="0">
                 <a:solidFill>
                   <a:srgbClr val="FFFFFF"/>
                 </a:solidFill>
@@ -3529,13 +3515,26 @@
               <a:t>Kshirja V </a:t>
             </a:r>
             <a:r>
-              <a:rPr>
+              <a:rPr sz="1400" dirty="0">
                 <a:solidFill>
                   <a:srgbClr val="C8C8C8"/>
                 </a:solidFill>
               </a:rPr>
-              <a:t>(Opportunity Scoring Engine &amp; Executive Visualization)</a:t>
-            </a:r>
+              <a:t>(</a:t>
+            </a:r>
+            <a:r>
+              <a:rPr lang="en-IN" sz="1400" dirty="0">
+                <a:solidFill>
+                  <a:srgbClr val="C8C8C8"/>
+                </a:solidFill>
+              </a:rPr>
+              <a:t>23BCE5079)</a:t>
+            </a:r>
+            <a:endParaRPr sz="1400" dirty="0">
+              <a:solidFill>
+                <a:srgbClr val="C8C8C8"/>
+              </a:solidFill>
+            </a:endParaRPr>
           </a:p>
           <a:p>
             <a:pPr>
@@ -3546,6 +3545,7 @@
               </a:defRPr>
             </a:pPr>
             <a:r>
+              <a:rPr sz="1400" dirty="0"/>
               <a:t>Deliverables: Live Working Prototype, Public Repository, Empirical Verification</a:t>
             </a:r>
           </a:p>
@@ -3568,7 +3568,7 @@
           <a:noFill/>
         </p:spPr>
         <p:txBody>
-          <a:bodyPr wrap="none" lIns="0" rIns="0" tIns="0" bIns="0">
+          <a:bodyPr wrap="none" lIns="0" tIns="0" rIns="0" bIns="0">
             <a:spAutoFit/>
           </a:bodyPr>
           <a:lstStyle/>
@@ -3604,7 +3604,7 @@
           <a:noFill/>
         </p:spPr>
         <p:txBody>
-          <a:bodyPr wrap="none" lIns="0" rIns="0" tIns="0" bIns="0">
+          <a:bodyPr wrap="none" lIns="0" tIns="0" rIns="0" bIns="0">
             <a:spAutoFit/>
           </a:bodyPr>
           <a:lstStyle/>
@@ -3632,7 +3632,7 @@
 </file>
 
 <file path=ppt/slides/slide10.xml><?xml version="1.0" encoding="utf-8"?>
-<p:sld xmlns:a="http://schemas.openxmlformats.org/drawingml/2006/main" xmlns:p="http://schemas.openxmlformats.org/presentationml/2006/main" xmlns:r="http://schemas.openxmlformats.org/officeDocument/2006/relationships">
+<p:sld xmlns:a="http://schemas.openxmlformats.org/drawingml/2006/main" xmlns:r="http://schemas.openxmlformats.org/officeDocument/2006/relationships" xmlns:p="http://schemas.openxmlformats.org/presentationml/2006/main">
   <p:cSld>
     <p:spTree>
       <p:nvGrpSpPr>
@@ -3640,7 +3640,14 @@
         <p:cNvGrpSpPr/>
         <p:nvPr/>
       </p:nvGrpSpPr>
-      <p:grpSpPr/>
+      <p:grpSpPr>
+        <a:xfrm>
+          <a:off x="0" y="0"/>
+          <a:ext cx="0" cy="0"/>
+          <a:chOff x="0" y="0"/>
+          <a:chExt cx="0" cy="0"/>
+        </a:xfrm>
+      </p:grpSpPr>
       <p:sp>
         <p:nvSpPr>
           <p:cNvPr id="2" name="Rectangle 1"/>
@@ -3681,6 +3688,7 @@
           <a:lstStyle/>
           <a:p>
             <a:pPr algn="ctr"/>
+            <a:endParaRPr/>
           </a:p>
         </p:txBody>
       </p:sp>
@@ -3701,7 +3709,7 @@
           <a:noFill/>
         </p:spPr>
         <p:txBody>
-          <a:bodyPr wrap="square" lIns="0" rIns="0" tIns="0" bIns="0">
+          <a:bodyPr wrap="square" lIns="0" tIns="0" rIns="0" bIns="0">
             <a:spAutoFit/>
           </a:bodyPr>
           <a:lstStyle/>
@@ -3737,7 +3745,7 @@
           <a:noFill/>
         </p:spPr>
         <p:txBody>
-          <a:bodyPr wrap="square" lIns="0" rIns="0" tIns="0" bIns="0">
+          <a:bodyPr wrap="square" lIns="0" tIns="0" rIns="0" bIns="0">
             <a:spAutoFit/>
           </a:bodyPr>
           <a:lstStyle/>
@@ -3773,7 +3781,7 @@
           <a:noFill/>
         </p:spPr>
         <p:txBody>
-          <a:bodyPr wrap="square" lIns="0" rIns="0" tIns="0" bIns="0">
+          <a:bodyPr wrap="square" lIns="0" tIns="0" rIns="0" bIns="0">
             <a:spAutoFit/>
           </a:bodyPr>
           <a:lstStyle/>
@@ -3832,6 +3840,7 @@
           <a:lstStyle/>
           <a:p>
             <a:pPr algn="ctr"/>
+            <a:endParaRPr/>
           </a:p>
         </p:txBody>
       </p:sp>
@@ -3854,15 +3863,39 @@
                 <a:tableStyleId>{5C22544A-7EE6-4342-B048-85BDC9FD1C3A}</a:tableStyleId>
               </a:tblPr>
               <a:tblGrid>
-                <a:gridCol w="3017520"/>
-                <a:gridCol w="2286000"/>
-                <a:gridCol w="2651760"/>
-                <a:gridCol w="2773375"/>
+                <a:gridCol w="3017520">
+                  <a:extLst>
+                    <a:ext uri="{9D8B030D-6E8A-4147-A177-3AD203B41FA5}">
+                      <a16:colId xmlns:a16="http://schemas.microsoft.com/office/drawing/2014/main" val="20000"/>
+                    </a:ext>
+                  </a:extLst>
+                </a:gridCol>
+                <a:gridCol w="2286000">
+                  <a:extLst>
+                    <a:ext uri="{9D8B030D-6E8A-4147-A177-3AD203B41FA5}">
+                      <a16:colId xmlns:a16="http://schemas.microsoft.com/office/drawing/2014/main" val="20001"/>
+                    </a:ext>
+                  </a:extLst>
+                </a:gridCol>
+                <a:gridCol w="2651760">
+                  <a:extLst>
+                    <a:ext uri="{9D8B030D-6E8A-4147-A177-3AD203B41FA5}">
+                      <a16:colId xmlns:a16="http://schemas.microsoft.com/office/drawing/2014/main" val="20002"/>
+                    </a:ext>
+                  </a:extLst>
+                </a:gridCol>
+                <a:gridCol w="2773375">
+                  <a:extLst>
+                    <a:ext uri="{9D8B030D-6E8A-4147-A177-3AD203B41FA5}">
+                      <a16:colId xmlns:a16="http://schemas.microsoft.com/office/drawing/2014/main" val="20003"/>
+                    </a:ext>
+                  </a:extLst>
+                </a:gridCol>
               </a:tblGrid>
               <a:tr h="633548">
                 <a:tc>
                   <a:txBody>
-                    <a:bodyPr wrap="square" lIns="73152" rIns="73152" tIns="54864" bIns="54864"/>
+                    <a:bodyPr/>
                     <a:lstStyle/>
                     <a:p>
                       <a:pPr>
@@ -3886,7 +3919,7 @@
                 </a:tc>
                 <a:tc>
                   <a:txBody>
-                    <a:bodyPr wrap="square" lIns="73152" rIns="73152" tIns="54864" bIns="54864"/>
+                    <a:bodyPr/>
                     <a:lstStyle/>
                     <a:p>
                       <a:pPr>
@@ -3910,7 +3943,7 @@
                 </a:tc>
                 <a:tc>
                   <a:txBody>
-                    <a:bodyPr wrap="square" lIns="73152" rIns="73152" tIns="54864" bIns="54864"/>
+                    <a:bodyPr/>
                     <a:lstStyle/>
                     <a:p>
                       <a:pPr>
@@ -3934,7 +3967,7 @@
                 </a:tc>
                 <a:tc>
                   <a:txBody>
-                    <a:bodyPr wrap="square" lIns="73152" rIns="73152" tIns="54864" bIns="54864"/>
+                    <a:bodyPr/>
                     <a:lstStyle/>
                     <a:p>
                       <a:pPr>
@@ -3956,11 +3989,16 @@
                     </a:solidFill>
                   </a:tcPr>
                 </a:tc>
+                <a:extLst>
+                  <a:ext uri="{0D108BD9-81ED-4DB2-BD59-A6C34878D82A}">
+                    <a16:rowId xmlns:a16="http://schemas.microsoft.com/office/drawing/2014/main" val="10000"/>
+                  </a:ext>
+                </a:extLst>
               </a:tr>
               <a:tr h="633548">
                 <a:tc>
                   <a:txBody>
-                    <a:bodyPr wrap="square" lIns="73152" rIns="73152"/>
+                    <a:bodyPr/>
                     <a:lstStyle/>
                     <a:p>
                       <a:pPr>
@@ -3984,7 +4022,7 @@
                 </a:tc>
                 <a:tc>
                   <a:txBody>
-                    <a:bodyPr wrap="square" lIns="73152" rIns="73152"/>
+                    <a:bodyPr/>
                     <a:lstStyle/>
                     <a:p>
                       <a:pPr>
@@ -4008,7 +4046,7 @@
                 </a:tc>
                 <a:tc>
                   <a:txBody>
-                    <a:bodyPr wrap="square" lIns="73152" rIns="73152"/>
+                    <a:bodyPr/>
                     <a:lstStyle/>
                     <a:p>
                       <a:pPr>
@@ -4032,7 +4070,7 @@
                 </a:tc>
                 <a:tc>
                   <a:txBody>
-                    <a:bodyPr wrap="square" lIns="73152" rIns="73152"/>
+                    <a:bodyPr/>
                     <a:lstStyle/>
                     <a:p>
                       <a:pPr>
@@ -4054,11 +4092,16 @@
                     </a:solidFill>
                   </a:tcPr>
                 </a:tc>
+                <a:extLst>
+                  <a:ext uri="{0D108BD9-81ED-4DB2-BD59-A6C34878D82A}">
+                    <a16:rowId xmlns:a16="http://schemas.microsoft.com/office/drawing/2014/main" val="10001"/>
+                  </a:ext>
+                </a:extLst>
               </a:tr>
               <a:tr h="633548">
                 <a:tc>
                   <a:txBody>
-                    <a:bodyPr wrap="square" lIns="73152" rIns="73152"/>
+                    <a:bodyPr/>
                     <a:lstStyle/>
                     <a:p>
                       <a:pPr>
@@ -4082,7 +4125,7 @@
                 </a:tc>
                 <a:tc>
                   <a:txBody>
-                    <a:bodyPr wrap="square" lIns="73152" rIns="73152"/>
+                    <a:bodyPr/>
                     <a:lstStyle/>
                     <a:p>
                       <a:pPr>
@@ -4106,7 +4149,7 @@
                 </a:tc>
                 <a:tc>
                   <a:txBody>
-                    <a:bodyPr wrap="square" lIns="73152" rIns="73152"/>
+                    <a:bodyPr/>
                     <a:lstStyle/>
                     <a:p>
                       <a:pPr>
@@ -4130,7 +4173,7 @@
                 </a:tc>
                 <a:tc>
                   <a:txBody>
-                    <a:bodyPr wrap="square" lIns="73152" rIns="73152"/>
+                    <a:bodyPr/>
                     <a:lstStyle/>
                     <a:p>
                       <a:pPr>
@@ -4152,11 +4195,16 @@
                     </a:solidFill>
                   </a:tcPr>
                 </a:tc>
+                <a:extLst>
+                  <a:ext uri="{0D108BD9-81ED-4DB2-BD59-A6C34878D82A}">
+                    <a16:rowId xmlns:a16="http://schemas.microsoft.com/office/drawing/2014/main" val="10002"/>
+                  </a:ext>
+                </a:extLst>
               </a:tr>
               <a:tr h="633548">
                 <a:tc>
                   <a:txBody>
-                    <a:bodyPr wrap="square" lIns="73152" rIns="73152"/>
+                    <a:bodyPr/>
                     <a:lstStyle/>
                     <a:p>
                       <a:pPr>
@@ -4180,7 +4228,7 @@
                 </a:tc>
                 <a:tc>
                   <a:txBody>
-                    <a:bodyPr wrap="square" lIns="73152" rIns="73152"/>
+                    <a:bodyPr/>
                     <a:lstStyle/>
                     <a:p>
                       <a:pPr>
@@ -4204,7 +4252,7 @@
                 </a:tc>
                 <a:tc>
                   <a:txBody>
-                    <a:bodyPr wrap="square" lIns="73152" rIns="73152"/>
+                    <a:bodyPr/>
                     <a:lstStyle/>
                     <a:p>
                       <a:pPr>
@@ -4228,7 +4276,7 @@
                 </a:tc>
                 <a:tc>
                   <a:txBody>
-                    <a:bodyPr wrap="square" lIns="73152" rIns="73152"/>
+                    <a:bodyPr/>
                     <a:lstStyle/>
                     <a:p>
                       <a:pPr>
@@ -4250,11 +4298,16 @@
                     </a:solidFill>
                   </a:tcPr>
                 </a:tc>
+                <a:extLst>
+                  <a:ext uri="{0D108BD9-81ED-4DB2-BD59-A6C34878D82A}">
+                    <a16:rowId xmlns:a16="http://schemas.microsoft.com/office/drawing/2014/main" val="10003"/>
+                  </a:ext>
+                </a:extLst>
               </a:tr>
               <a:tr h="633548">
                 <a:tc>
                   <a:txBody>
-                    <a:bodyPr wrap="square" lIns="73152" rIns="73152"/>
+                    <a:bodyPr/>
                     <a:lstStyle/>
                     <a:p>
                       <a:pPr>
@@ -4278,7 +4331,7 @@
                 </a:tc>
                 <a:tc>
                   <a:txBody>
-                    <a:bodyPr wrap="square" lIns="73152" rIns="73152"/>
+                    <a:bodyPr/>
                     <a:lstStyle/>
                     <a:p>
                       <a:pPr>
@@ -4302,7 +4355,7 @@
                 </a:tc>
                 <a:tc>
                   <a:txBody>
-                    <a:bodyPr wrap="square" lIns="73152" rIns="73152"/>
+                    <a:bodyPr/>
                     <a:lstStyle/>
                     <a:p>
                       <a:pPr>
@@ -4326,7 +4379,7 @@
                 </a:tc>
                 <a:tc>
                   <a:txBody>
-                    <a:bodyPr wrap="square" lIns="73152" rIns="73152"/>
+                    <a:bodyPr/>
                     <a:lstStyle/>
                     <a:p>
                       <a:pPr>
@@ -4348,11 +4401,16 @@
                     </a:solidFill>
                   </a:tcPr>
                 </a:tc>
+                <a:extLst>
+                  <a:ext uri="{0D108BD9-81ED-4DB2-BD59-A6C34878D82A}">
+                    <a16:rowId xmlns:a16="http://schemas.microsoft.com/office/drawing/2014/main" val="10004"/>
+                  </a:ext>
+                </a:extLst>
               </a:tr>
               <a:tr h="633548">
                 <a:tc>
                   <a:txBody>
-                    <a:bodyPr wrap="square" lIns="73152" rIns="73152"/>
+                    <a:bodyPr/>
                     <a:lstStyle/>
                     <a:p>
                       <a:pPr>
@@ -4376,7 +4434,7 @@
                 </a:tc>
                 <a:tc>
                   <a:txBody>
-                    <a:bodyPr wrap="square" lIns="73152" rIns="73152"/>
+                    <a:bodyPr/>
                     <a:lstStyle/>
                     <a:p>
                       <a:pPr>
@@ -4400,7 +4458,7 @@
                 </a:tc>
                 <a:tc>
                   <a:txBody>
-                    <a:bodyPr wrap="square" lIns="73152" rIns="73152"/>
+                    <a:bodyPr/>
                     <a:lstStyle/>
                     <a:p>
                       <a:pPr>
@@ -4424,7 +4482,7 @@
                 </a:tc>
                 <a:tc>
                   <a:txBody>
-                    <a:bodyPr wrap="square" lIns="73152" rIns="73152"/>
+                    <a:bodyPr/>
                     <a:lstStyle/>
                     <a:p>
                       <a:pPr>
@@ -4446,11 +4504,16 @@
                     </a:solidFill>
                   </a:tcPr>
                 </a:tc>
+                <a:extLst>
+                  <a:ext uri="{0D108BD9-81ED-4DB2-BD59-A6C34878D82A}">
+                    <a16:rowId xmlns:a16="http://schemas.microsoft.com/office/drawing/2014/main" val="10005"/>
+                  </a:ext>
+                </a:extLst>
               </a:tr>
               <a:tr h="633552">
                 <a:tc>
                   <a:txBody>
-                    <a:bodyPr wrap="square" lIns="73152" rIns="73152"/>
+                    <a:bodyPr/>
                     <a:lstStyle/>
                     <a:p>
                       <a:pPr>
@@ -4474,7 +4537,7 @@
                 </a:tc>
                 <a:tc>
                   <a:txBody>
-                    <a:bodyPr wrap="square" lIns="73152" rIns="73152"/>
+                    <a:bodyPr/>
                     <a:lstStyle/>
                     <a:p>
                       <a:pPr>
@@ -4498,7 +4561,7 @@
                 </a:tc>
                 <a:tc>
                   <a:txBody>
-                    <a:bodyPr wrap="square" lIns="73152" rIns="73152"/>
+                    <a:bodyPr/>
                     <a:lstStyle/>
                     <a:p>
                       <a:pPr>
@@ -4522,7 +4585,7 @@
                 </a:tc>
                 <a:tc>
                   <a:txBody>
-                    <a:bodyPr wrap="square" lIns="73152" rIns="73152"/>
+                    <a:bodyPr/>
                     <a:lstStyle/>
                     <a:p>
                       <a:pPr>
@@ -4544,6 +4607,11 @@
                     </a:solidFill>
                   </a:tcPr>
                 </a:tc>
+                <a:extLst>
+                  <a:ext uri="{0D108BD9-81ED-4DB2-BD59-A6C34878D82A}">
+                    <a16:rowId xmlns:a16="http://schemas.microsoft.com/office/drawing/2014/main" val="10006"/>
+                  </a:ext>
+                </a:extLst>
               </a:tr>
             </a:tbl>
           </a:graphicData>
@@ -4566,7 +4634,7 @@
           <a:noFill/>
         </p:spPr>
         <p:txBody>
-          <a:bodyPr wrap="none" lIns="0" rIns="0" tIns="0" bIns="0">
+          <a:bodyPr wrap="none" lIns="0" tIns="0" rIns="0" bIns="0">
             <a:spAutoFit/>
           </a:bodyPr>
           <a:lstStyle/>
@@ -4602,7 +4670,7 @@
           <a:noFill/>
         </p:spPr>
         <p:txBody>
-          <a:bodyPr wrap="none" lIns="0" rIns="0" tIns="0" bIns="0">
+          <a:bodyPr wrap="none" lIns="0" tIns="0" rIns="0" bIns="0">
             <a:spAutoFit/>
           </a:bodyPr>
           <a:lstStyle/>
@@ -4630,7 +4698,7 @@
 </file>
 
 <file path=ppt/slides/slide11.xml><?xml version="1.0" encoding="utf-8"?>
-<p:sld xmlns:a="http://schemas.openxmlformats.org/drawingml/2006/main" xmlns:p="http://schemas.openxmlformats.org/presentationml/2006/main" xmlns:r="http://schemas.openxmlformats.org/officeDocument/2006/relationships">
+<p:sld xmlns:a="http://schemas.openxmlformats.org/drawingml/2006/main" xmlns:r="http://schemas.openxmlformats.org/officeDocument/2006/relationships" xmlns:p="http://schemas.openxmlformats.org/presentationml/2006/main">
   <p:cSld>
     <p:spTree>
       <p:nvGrpSpPr>
@@ -4638,7 +4706,14 @@
         <p:cNvGrpSpPr/>
         <p:nvPr/>
       </p:nvGrpSpPr>
-      <p:grpSpPr/>
+      <p:grpSpPr>
+        <a:xfrm>
+          <a:off x="0" y="0"/>
+          <a:ext cx="0" cy="0"/>
+          <a:chOff x="0" y="0"/>
+          <a:chExt cx="0" cy="0"/>
+        </a:xfrm>
+      </p:grpSpPr>
       <p:sp>
         <p:nvSpPr>
           <p:cNvPr id="2" name="Rectangle 1"/>
@@ -4679,6 +4754,7 @@
           <a:lstStyle/>
           <a:p>
             <a:pPr algn="ctr"/>
+            <a:endParaRPr/>
           </a:p>
         </p:txBody>
       </p:sp>
@@ -4699,7 +4775,7 @@
           <a:noFill/>
         </p:spPr>
         <p:txBody>
-          <a:bodyPr wrap="square" lIns="0" rIns="0" tIns="0" bIns="0">
+          <a:bodyPr wrap="square" lIns="0" tIns="0" rIns="0" bIns="0">
             <a:spAutoFit/>
           </a:bodyPr>
           <a:lstStyle/>
@@ -4735,7 +4811,7 @@
           <a:noFill/>
         </p:spPr>
         <p:txBody>
-          <a:bodyPr wrap="square" lIns="0" rIns="0" tIns="0" bIns="0">
+          <a:bodyPr wrap="square" lIns="0" tIns="0" rIns="0" bIns="0">
             <a:spAutoFit/>
           </a:bodyPr>
           <a:lstStyle/>
@@ -4771,7 +4847,7 @@
           <a:noFill/>
         </p:spPr>
         <p:txBody>
-          <a:bodyPr wrap="square" lIns="0" rIns="0" tIns="0" bIns="0">
+          <a:bodyPr wrap="square" lIns="0" tIns="0" rIns="0" bIns="0">
             <a:spAutoFit/>
           </a:bodyPr>
           <a:lstStyle/>
@@ -4830,6 +4906,7 @@
           <a:lstStyle/>
           <a:p>
             <a:pPr algn="ctr"/>
+            <a:endParaRPr/>
           </a:p>
         </p:txBody>
       </p:sp>
@@ -4852,20 +4929,74 @@
                 <a:tableStyleId>{5C22544A-7EE6-4342-B048-85BDC9FD1C3A}</a:tableStyleId>
               </a:tblPr>
               <a:tblGrid>
-                <a:gridCol w="2103120"/>
-                <a:gridCol w="1005840"/>
-                <a:gridCol w="822960"/>
-                <a:gridCol w="822960"/>
-                <a:gridCol w="822960"/>
-                <a:gridCol w="822960"/>
-                <a:gridCol w="822960"/>
-                <a:gridCol w="1280160"/>
-                <a:gridCol w="2224735"/>
+                <a:gridCol w="2103120">
+                  <a:extLst>
+                    <a:ext uri="{9D8B030D-6E8A-4147-A177-3AD203B41FA5}">
+                      <a16:colId xmlns:a16="http://schemas.microsoft.com/office/drawing/2014/main" val="20000"/>
+                    </a:ext>
+                  </a:extLst>
+                </a:gridCol>
+                <a:gridCol w="1005840">
+                  <a:extLst>
+                    <a:ext uri="{9D8B030D-6E8A-4147-A177-3AD203B41FA5}">
+                      <a16:colId xmlns:a16="http://schemas.microsoft.com/office/drawing/2014/main" val="20001"/>
+                    </a:ext>
+                  </a:extLst>
+                </a:gridCol>
+                <a:gridCol w="822960">
+                  <a:extLst>
+                    <a:ext uri="{9D8B030D-6E8A-4147-A177-3AD203B41FA5}">
+                      <a16:colId xmlns:a16="http://schemas.microsoft.com/office/drawing/2014/main" val="20002"/>
+                    </a:ext>
+                  </a:extLst>
+                </a:gridCol>
+                <a:gridCol w="822960">
+                  <a:extLst>
+                    <a:ext uri="{9D8B030D-6E8A-4147-A177-3AD203B41FA5}">
+                      <a16:colId xmlns:a16="http://schemas.microsoft.com/office/drawing/2014/main" val="20003"/>
+                    </a:ext>
+                  </a:extLst>
+                </a:gridCol>
+                <a:gridCol w="822960">
+                  <a:extLst>
+                    <a:ext uri="{9D8B030D-6E8A-4147-A177-3AD203B41FA5}">
+                      <a16:colId xmlns:a16="http://schemas.microsoft.com/office/drawing/2014/main" val="20004"/>
+                    </a:ext>
+                  </a:extLst>
+                </a:gridCol>
+                <a:gridCol w="822960">
+                  <a:extLst>
+                    <a:ext uri="{9D8B030D-6E8A-4147-A177-3AD203B41FA5}">
+                      <a16:colId xmlns:a16="http://schemas.microsoft.com/office/drawing/2014/main" val="20005"/>
+                    </a:ext>
+                  </a:extLst>
+                </a:gridCol>
+                <a:gridCol w="822960">
+                  <a:extLst>
+                    <a:ext uri="{9D8B030D-6E8A-4147-A177-3AD203B41FA5}">
+                      <a16:colId xmlns:a16="http://schemas.microsoft.com/office/drawing/2014/main" val="20006"/>
+                    </a:ext>
+                  </a:extLst>
+                </a:gridCol>
+                <a:gridCol w="1280160">
+                  <a:extLst>
+                    <a:ext uri="{9D8B030D-6E8A-4147-A177-3AD203B41FA5}">
+                      <a16:colId xmlns:a16="http://schemas.microsoft.com/office/drawing/2014/main" val="20007"/>
+                    </a:ext>
+                  </a:extLst>
+                </a:gridCol>
+                <a:gridCol w="2224735">
+                  <a:extLst>
+                    <a:ext uri="{9D8B030D-6E8A-4147-A177-3AD203B41FA5}">
+                      <a16:colId xmlns:a16="http://schemas.microsoft.com/office/drawing/2014/main" val="20008"/>
+                    </a:ext>
+                  </a:extLst>
+                </a:gridCol>
               </a:tblGrid>
               <a:tr h="886968">
                 <a:tc>
                   <a:txBody>
-                    <a:bodyPr wrap="square" lIns="73152" rIns="73152" tIns="54864" bIns="54864"/>
+                    <a:bodyPr/>
                     <a:lstStyle/>
                     <a:p>
                       <a:pPr>
@@ -4889,7 +5020,7 @@
                 </a:tc>
                 <a:tc>
                   <a:txBody>
-                    <a:bodyPr wrap="square" lIns="73152" rIns="73152" tIns="54864" bIns="54864"/>
+                    <a:bodyPr/>
                     <a:lstStyle/>
                     <a:p>
                       <a:pPr>
@@ -4913,7 +5044,7 @@
                 </a:tc>
                 <a:tc>
                   <a:txBody>
-                    <a:bodyPr wrap="square" lIns="73152" rIns="73152" tIns="54864" bIns="54864"/>
+                    <a:bodyPr/>
                     <a:lstStyle/>
                     <a:p>
                       <a:pPr>
@@ -4937,7 +5068,7 @@
                 </a:tc>
                 <a:tc>
                   <a:txBody>
-                    <a:bodyPr wrap="square" lIns="73152" rIns="73152" tIns="54864" bIns="54864"/>
+                    <a:bodyPr/>
                     <a:lstStyle/>
                     <a:p>
                       <a:pPr>
@@ -4961,7 +5092,7 @@
                 </a:tc>
                 <a:tc>
                   <a:txBody>
-                    <a:bodyPr wrap="square" lIns="73152" rIns="73152" tIns="54864" bIns="54864"/>
+                    <a:bodyPr/>
                     <a:lstStyle/>
                     <a:p>
                       <a:pPr>
@@ -4985,7 +5116,7 @@
                 </a:tc>
                 <a:tc>
                   <a:txBody>
-                    <a:bodyPr wrap="square" lIns="73152" rIns="73152" tIns="54864" bIns="54864"/>
+                    <a:bodyPr/>
                     <a:lstStyle/>
                     <a:p>
                       <a:pPr>
@@ -5009,7 +5140,7 @@
                 </a:tc>
                 <a:tc>
                   <a:txBody>
-                    <a:bodyPr wrap="square" lIns="73152" rIns="73152" tIns="54864" bIns="54864"/>
+                    <a:bodyPr/>
                     <a:lstStyle/>
                     <a:p>
                       <a:pPr>
@@ -5033,7 +5164,7 @@
                 </a:tc>
                 <a:tc>
                   <a:txBody>
-                    <a:bodyPr wrap="square" lIns="73152" rIns="73152" tIns="54864" bIns="54864"/>
+                    <a:bodyPr/>
                     <a:lstStyle/>
                     <a:p>
                       <a:pPr>
@@ -5057,7 +5188,7 @@
                 </a:tc>
                 <a:tc>
                   <a:txBody>
-                    <a:bodyPr wrap="square" lIns="73152" rIns="73152" tIns="54864" bIns="54864"/>
+                    <a:bodyPr/>
                     <a:lstStyle/>
                     <a:p>
                       <a:pPr>
@@ -5079,11 +5210,16 @@
                     </a:solidFill>
                   </a:tcPr>
                 </a:tc>
+                <a:extLst>
+                  <a:ext uri="{0D108BD9-81ED-4DB2-BD59-A6C34878D82A}">
+                    <a16:rowId xmlns:a16="http://schemas.microsoft.com/office/drawing/2014/main" val="10000"/>
+                  </a:ext>
+                </a:extLst>
               </a:tr>
               <a:tr h="886968">
                 <a:tc>
                   <a:txBody>
-                    <a:bodyPr wrap="square" lIns="73152" rIns="73152"/>
+                    <a:bodyPr/>
                     <a:lstStyle/>
                     <a:p>
                       <a:pPr>
@@ -5111,7 +5247,7 @@
                 </a:tc>
                 <a:tc>
                   <a:txBody>
-                    <a:bodyPr wrap="square" lIns="73152" rIns="73152"/>
+                    <a:bodyPr/>
                     <a:lstStyle/>
                     <a:p>
                       <a:pPr>
@@ -5135,7 +5271,7 @@
                 </a:tc>
                 <a:tc>
                   <a:txBody>
-                    <a:bodyPr wrap="square" lIns="73152" rIns="73152"/>
+                    <a:bodyPr/>
                     <a:lstStyle/>
                     <a:p>
                       <a:pPr>
@@ -5159,7 +5295,7 @@
                 </a:tc>
                 <a:tc>
                   <a:txBody>
-                    <a:bodyPr wrap="square" lIns="73152" rIns="73152"/>
+                    <a:bodyPr/>
                     <a:lstStyle/>
                     <a:p>
                       <a:pPr>
@@ -5183,7 +5319,7 @@
                 </a:tc>
                 <a:tc>
                   <a:txBody>
-                    <a:bodyPr wrap="square" lIns="73152" rIns="73152"/>
+                    <a:bodyPr/>
                     <a:lstStyle/>
                     <a:p>
                       <a:pPr>
@@ -5207,7 +5343,7 @@
                 </a:tc>
                 <a:tc>
                   <a:txBody>
-                    <a:bodyPr wrap="square" lIns="73152" rIns="73152"/>
+                    <a:bodyPr/>
                     <a:lstStyle/>
                     <a:p>
                       <a:pPr>
@@ -5231,7 +5367,7 @@
                 </a:tc>
                 <a:tc>
                   <a:txBody>
-                    <a:bodyPr wrap="square" lIns="73152" rIns="73152"/>
+                    <a:bodyPr/>
                     <a:lstStyle/>
                     <a:p>
                       <a:pPr>
@@ -5255,7 +5391,7 @@
                 </a:tc>
                 <a:tc>
                   <a:txBody>
-                    <a:bodyPr wrap="square" lIns="73152" rIns="73152"/>
+                    <a:bodyPr/>
                     <a:lstStyle/>
                     <a:p>
                       <a:pPr>
@@ -5279,7 +5415,7 @@
                 </a:tc>
                 <a:tc>
                   <a:txBody>
-                    <a:bodyPr wrap="square" lIns="73152" rIns="73152"/>
+                    <a:bodyPr/>
                     <a:lstStyle/>
                     <a:p>
                       <a:pPr>
@@ -5305,11 +5441,16 @@
                     </a:solidFill>
                   </a:tcPr>
                 </a:tc>
+                <a:extLst>
+                  <a:ext uri="{0D108BD9-81ED-4DB2-BD59-A6C34878D82A}">
+                    <a16:rowId xmlns:a16="http://schemas.microsoft.com/office/drawing/2014/main" val="10001"/>
+                  </a:ext>
+                </a:extLst>
               </a:tr>
               <a:tr h="886968">
                 <a:tc>
                   <a:txBody>
-                    <a:bodyPr wrap="square" lIns="73152" rIns="73152"/>
+                    <a:bodyPr/>
                     <a:lstStyle/>
                     <a:p>
                       <a:pPr>
@@ -5337,7 +5478,7 @@
                 </a:tc>
                 <a:tc>
                   <a:txBody>
-                    <a:bodyPr wrap="square" lIns="73152" rIns="73152"/>
+                    <a:bodyPr/>
                     <a:lstStyle/>
                     <a:p>
                       <a:pPr>
@@ -5361,7 +5502,7 @@
                 </a:tc>
                 <a:tc>
                   <a:txBody>
-                    <a:bodyPr wrap="square" lIns="73152" rIns="73152"/>
+                    <a:bodyPr/>
                     <a:lstStyle/>
                     <a:p>
                       <a:pPr>
@@ -5385,7 +5526,7 @@
                 </a:tc>
                 <a:tc>
                   <a:txBody>
-                    <a:bodyPr wrap="square" lIns="73152" rIns="73152"/>
+                    <a:bodyPr/>
                     <a:lstStyle/>
                     <a:p>
                       <a:pPr>
@@ -5409,7 +5550,7 @@
                 </a:tc>
                 <a:tc>
                   <a:txBody>
-                    <a:bodyPr wrap="square" lIns="73152" rIns="73152"/>
+                    <a:bodyPr/>
                     <a:lstStyle/>
                     <a:p>
                       <a:pPr>
@@ -5433,7 +5574,7 @@
                 </a:tc>
                 <a:tc>
                   <a:txBody>
-                    <a:bodyPr wrap="square" lIns="73152" rIns="73152"/>
+                    <a:bodyPr/>
                     <a:lstStyle/>
                     <a:p>
                       <a:pPr>
@@ -5457,7 +5598,7 @@
                 </a:tc>
                 <a:tc>
                   <a:txBody>
-                    <a:bodyPr wrap="square" lIns="73152" rIns="73152"/>
+                    <a:bodyPr/>
                     <a:lstStyle/>
                     <a:p>
                       <a:pPr>
@@ -5481,7 +5622,7 @@
                 </a:tc>
                 <a:tc>
                   <a:txBody>
-                    <a:bodyPr wrap="square" lIns="73152" rIns="73152"/>
+                    <a:bodyPr/>
                     <a:lstStyle/>
                     <a:p>
                       <a:pPr>
@@ -5505,7 +5646,7 @@
                 </a:tc>
                 <a:tc>
                   <a:txBody>
-                    <a:bodyPr wrap="square" lIns="73152" rIns="73152"/>
+                    <a:bodyPr/>
                     <a:lstStyle/>
                     <a:p>
                       <a:pPr>
@@ -5531,11 +5672,16 @@
                     </a:solidFill>
                   </a:tcPr>
                 </a:tc>
+                <a:extLst>
+                  <a:ext uri="{0D108BD9-81ED-4DB2-BD59-A6C34878D82A}">
+                    <a16:rowId xmlns:a16="http://schemas.microsoft.com/office/drawing/2014/main" val="10002"/>
+                  </a:ext>
+                </a:extLst>
               </a:tr>
               <a:tr h="886968">
                 <a:tc>
                   <a:txBody>
-                    <a:bodyPr wrap="square" lIns="73152" rIns="73152"/>
+                    <a:bodyPr/>
                     <a:lstStyle/>
                     <a:p>
                       <a:pPr>
@@ -5563,7 +5709,7 @@
                 </a:tc>
                 <a:tc>
                   <a:txBody>
-                    <a:bodyPr wrap="square" lIns="73152" rIns="73152"/>
+                    <a:bodyPr/>
                     <a:lstStyle/>
                     <a:p>
                       <a:pPr>
@@ -5587,7 +5733,7 @@
                 </a:tc>
                 <a:tc>
                   <a:txBody>
-                    <a:bodyPr wrap="square" lIns="73152" rIns="73152"/>
+                    <a:bodyPr/>
                     <a:lstStyle/>
                     <a:p>
                       <a:pPr>
@@ -5611,7 +5757,7 @@
                 </a:tc>
                 <a:tc>
                   <a:txBody>
-                    <a:bodyPr wrap="square" lIns="73152" rIns="73152"/>
+                    <a:bodyPr/>
                     <a:lstStyle/>
                     <a:p>
                       <a:pPr>
@@ -5635,7 +5781,7 @@
                 </a:tc>
                 <a:tc>
                   <a:txBody>
-                    <a:bodyPr wrap="square" lIns="73152" rIns="73152"/>
+                    <a:bodyPr/>
                     <a:lstStyle/>
                     <a:p>
                       <a:pPr>
@@ -5659,7 +5805,7 @@
                 </a:tc>
                 <a:tc>
                   <a:txBody>
-                    <a:bodyPr wrap="square" lIns="73152" rIns="73152"/>
+                    <a:bodyPr/>
                     <a:lstStyle/>
                     <a:p>
                       <a:pPr>
@@ -5683,7 +5829,7 @@
                 </a:tc>
                 <a:tc>
                   <a:txBody>
-                    <a:bodyPr wrap="square" lIns="73152" rIns="73152"/>
+                    <a:bodyPr/>
                     <a:lstStyle/>
                     <a:p>
                       <a:pPr>
@@ -5707,7 +5853,7 @@
                 </a:tc>
                 <a:tc>
                   <a:txBody>
-                    <a:bodyPr wrap="square" lIns="73152" rIns="73152"/>
+                    <a:bodyPr/>
                     <a:lstStyle/>
                     <a:p>
                       <a:pPr>
@@ -5731,7 +5877,7 @@
                 </a:tc>
                 <a:tc>
                   <a:txBody>
-                    <a:bodyPr wrap="square" lIns="73152" rIns="73152"/>
+                    <a:bodyPr/>
                     <a:lstStyle/>
                     <a:p>
                       <a:pPr>
@@ -5757,11 +5903,16 @@
                     </a:solidFill>
                   </a:tcPr>
                 </a:tc>
+                <a:extLst>
+                  <a:ext uri="{0D108BD9-81ED-4DB2-BD59-A6C34878D82A}">
+                    <a16:rowId xmlns:a16="http://schemas.microsoft.com/office/drawing/2014/main" val="10003"/>
+                  </a:ext>
+                </a:extLst>
               </a:tr>
               <a:tr h="886968">
                 <a:tc>
                   <a:txBody>
-                    <a:bodyPr wrap="square" lIns="73152" rIns="73152"/>
+                    <a:bodyPr/>
                     <a:lstStyle/>
                     <a:p>
                       <a:pPr>
@@ -5789,7 +5940,7 @@
                 </a:tc>
                 <a:tc>
                   <a:txBody>
-                    <a:bodyPr wrap="square" lIns="73152" rIns="73152"/>
+                    <a:bodyPr/>
                     <a:lstStyle/>
                     <a:p>
                       <a:pPr>
@@ -5813,7 +5964,7 @@
                 </a:tc>
                 <a:tc>
                   <a:txBody>
-                    <a:bodyPr wrap="square" lIns="73152" rIns="73152"/>
+                    <a:bodyPr/>
                     <a:lstStyle/>
                     <a:p>
                       <a:pPr>
@@ -5837,7 +5988,7 @@
                 </a:tc>
                 <a:tc>
                   <a:txBody>
-                    <a:bodyPr wrap="square" lIns="73152" rIns="73152"/>
+                    <a:bodyPr/>
                     <a:lstStyle/>
                     <a:p>
                       <a:pPr>
@@ -5861,7 +6012,7 @@
                 </a:tc>
                 <a:tc>
                   <a:txBody>
-                    <a:bodyPr wrap="square" lIns="73152" rIns="73152"/>
+                    <a:bodyPr/>
                     <a:lstStyle/>
                     <a:p>
                       <a:pPr>
@@ -5885,7 +6036,7 @@
                 </a:tc>
                 <a:tc>
                   <a:txBody>
-                    <a:bodyPr wrap="square" lIns="73152" rIns="73152"/>
+                    <a:bodyPr/>
                     <a:lstStyle/>
                     <a:p>
                       <a:pPr>
@@ -5909,7 +6060,7 @@
                 </a:tc>
                 <a:tc>
                   <a:txBody>
-                    <a:bodyPr wrap="square" lIns="73152" rIns="73152"/>
+                    <a:bodyPr/>
                     <a:lstStyle/>
                     <a:p>
                       <a:pPr>
@@ -5933,7 +6084,7 @@
                 </a:tc>
                 <a:tc>
                   <a:txBody>
-                    <a:bodyPr wrap="square" lIns="73152" rIns="73152"/>
+                    <a:bodyPr/>
                     <a:lstStyle/>
                     <a:p>
                       <a:pPr>
@@ -5957,7 +6108,7 @@
                 </a:tc>
                 <a:tc>
                   <a:txBody>
-                    <a:bodyPr wrap="square" lIns="73152" rIns="73152"/>
+                    <a:bodyPr/>
                     <a:lstStyle/>
                     <a:p>
                       <a:pPr>
@@ -5983,6 +6134,11 @@
                     </a:solidFill>
                   </a:tcPr>
                 </a:tc>
+                <a:extLst>
+                  <a:ext uri="{0D108BD9-81ED-4DB2-BD59-A6C34878D82A}">
+                    <a16:rowId xmlns:a16="http://schemas.microsoft.com/office/drawing/2014/main" val="10004"/>
+                  </a:ext>
+                </a:extLst>
               </a:tr>
             </a:tbl>
           </a:graphicData>
@@ -6005,7 +6161,7 @@
           <a:noFill/>
         </p:spPr>
         <p:txBody>
-          <a:bodyPr wrap="none" lIns="0" rIns="0" tIns="0" bIns="0">
+          <a:bodyPr wrap="none" lIns="0" tIns="0" rIns="0" bIns="0">
             <a:spAutoFit/>
           </a:bodyPr>
           <a:lstStyle/>
@@ -6041,7 +6197,7 @@
           <a:noFill/>
         </p:spPr>
         <p:txBody>
-          <a:bodyPr wrap="none" lIns="0" rIns="0" tIns="0" bIns="0">
+          <a:bodyPr wrap="none" lIns="0" tIns="0" rIns="0" bIns="0">
             <a:spAutoFit/>
           </a:bodyPr>
           <a:lstStyle/>
@@ -6069,7 +6225,7 @@
 </file>
 
 <file path=ppt/slides/slide12.xml><?xml version="1.0" encoding="utf-8"?>
-<p:sld xmlns:a="http://schemas.openxmlformats.org/drawingml/2006/main" xmlns:p="http://schemas.openxmlformats.org/presentationml/2006/main" xmlns:r="http://schemas.openxmlformats.org/officeDocument/2006/relationships">
+<p:sld xmlns:a="http://schemas.openxmlformats.org/drawingml/2006/main" xmlns:r="http://schemas.openxmlformats.org/officeDocument/2006/relationships" xmlns:p="http://schemas.openxmlformats.org/presentationml/2006/main">
   <p:cSld>
     <p:spTree>
       <p:nvGrpSpPr>
@@ -6077,7 +6233,14 @@
         <p:cNvGrpSpPr/>
         <p:nvPr/>
       </p:nvGrpSpPr>
-      <p:grpSpPr/>
+      <p:grpSpPr>
+        <a:xfrm>
+          <a:off x="0" y="0"/>
+          <a:ext cx="0" cy="0"/>
+          <a:chOff x="0" y="0"/>
+          <a:chExt cx="0" cy="0"/>
+        </a:xfrm>
+      </p:grpSpPr>
       <p:sp>
         <p:nvSpPr>
           <p:cNvPr id="2" name="Rectangle 1"/>
@@ -6118,6 +6281,7 @@
           <a:lstStyle/>
           <a:p>
             <a:pPr algn="ctr"/>
+            <a:endParaRPr/>
           </a:p>
         </p:txBody>
       </p:sp>
@@ -6138,7 +6302,7 @@
           <a:noFill/>
         </p:spPr>
         <p:txBody>
-          <a:bodyPr wrap="square" lIns="0" rIns="0" tIns="0" bIns="0">
+          <a:bodyPr wrap="square" lIns="0" tIns="0" rIns="0" bIns="0">
             <a:spAutoFit/>
           </a:bodyPr>
           <a:lstStyle/>
@@ -6174,7 +6338,7 @@
           <a:noFill/>
         </p:spPr>
         <p:txBody>
-          <a:bodyPr wrap="square" lIns="0" rIns="0" tIns="0" bIns="0">
+          <a:bodyPr wrap="square" lIns="0" tIns="0" rIns="0" bIns="0">
             <a:spAutoFit/>
           </a:bodyPr>
           <a:lstStyle/>
@@ -6210,7 +6374,7 @@
           <a:noFill/>
         </p:spPr>
         <p:txBody>
-          <a:bodyPr wrap="square" lIns="0" rIns="0" tIns="0" bIns="0">
+          <a:bodyPr wrap="square" lIns="0" tIns="0" rIns="0" bIns="0">
             <a:spAutoFit/>
           </a:bodyPr>
           <a:lstStyle/>
@@ -6269,6 +6433,7 @@
           <a:lstStyle/>
           <a:p>
             <a:pPr algn="ctr"/>
+            <a:endParaRPr/>
           </a:p>
         </p:txBody>
       </p:sp>
@@ -6314,6 +6479,7 @@
           <a:lstStyle/>
           <a:p>
             <a:pPr algn="ctr"/>
+            <a:endParaRPr/>
           </a:p>
         </p:txBody>
       </p:sp>
@@ -6425,6 +6591,7 @@
           <a:lstStyle/>
           <a:p>
             <a:pPr algn="ctr"/>
+            <a:endParaRPr/>
           </a:p>
         </p:txBody>
       </p:sp>
@@ -6542,6 +6709,7 @@
           <a:lstStyle/>
           <a:p>
             <a:pPr algn="ctr"/>
+            <a:endParaRPr/>
           </a:p>
         </p:txBody>
       </p:sp>
@@ -6653,6 +6821,7 @@
           <a:lstStyle/>
           <a:p>
             <a:pPr algn="ctr"/>
+            <a:endParaRPr/>
           </a:p>
         </p:txBody>
       </p:sp>
@@ -6739,7 +6908,7 @@
           <a:noFill/>
         </p:spPr>
         <p:txBody>
-          <a:bodyPr wrap="none" lIns="0" rIns="0" tIns="0" bIns="0">
+          <a:bodyPr wrap="none" lIns="0" tIns="0" rIns="0" bIns="0">
             <a:spAutoFit/>
           </a:bodyPr>
           <a:lstStyle/>
@@ -6775,7 +6944,7 @@
           <a:noFill/>
         </p:spPr>
         <p:txBody>
-          <a:bodyPr wrap="none" lIns="0" rIns="0" tIns="0" bIns="0">
+          <a:bodyPr wrap="none" lIns="0" tIns="0" rIns="0" bIns="0">
             <a:spAutoFit/>
           </a:bodyPr>
           <a:lstStyle/>
@@ -6803,7 +6972,7 @@
 </file>
 
 <file path=ppt/slides/slide13.xml><?xml version="1.0" encoding="utf-8"?>
-<p:sld xmlns:a="http://schemas.openxmlformats.org/drawingml/2006/main" xmlns:p="http://schemas.openxmlformats.org/presentationml/2006/main" xmlns:r="http://schemas.openxmlformats.org/officeDocument/2006/relationships">
+<p:sld xmlns:a="http://schemas.openxmlformats.org/drawingml/2006/main" xmlns:r="http://schemas.openxmlformats.org/officeDocument/2006/relationships" xmlns:p="http://schemas.openxmlformats.org/presentationml/2006/main">
   <p:cSld>
     <p:spTree>
       <p:nvGrpSpPr>
@@ -6811,7 +6980,14 @@
         <p:cNvGrpSpPr/>
         <p:nvPr/>
       </p:nvGrpSpPr>
-      <p:grpSpPr/>
+      <p:grpSpPr>
+        <a:xfrm>
+          <a:off x="0" y="0"/>
+          <a:ext cx="0" cy="0"/>
+          <a:chOff x="0" y="0"/>
+          <a:chExt cx="0" cy="0"/>
+        </a:xfrm>
+      </p:grpSpPr>
       <p:sp>
         <p:nvSpPr>
           <p:cNvPr id="2" name="Rectangle 1"/>
@@ -6852,6 +7028,7 @@
           <a:lstStyle/>
           <a:p>
             <a:pPr algn="ctr"/>
+            <a:endParaRPr/>
           </a:p>
         </p:txBody>
       </p:sp>
@@ -6872,7 +7049,7 @@
           <a:noFill/>
         </p:spPr>
         <p:txBody>
-          <a:bodyPr wrap="square" lIns="0" rIns="0" tIns="0" bIns="0">
+          <a:bodyPr wrap="square" lIns="0" tIns="0" rIns="0" bIns="0">
             <a:spAutoFit/>
           </a:bodyPr>
           <a:lstStyle/>
@@ -6908,7 +7085,7 @@
           <a:noFill/>
         </p:spPr>
         <p:txBody>
-          <a:bodyPr wrap="square" lIns="0" rIns="0" tIns="0" bIns="0">
+          <a:bodyPr wrap="square" lIns="0" tIns="0" rIns="0" bIns="0">
             <a:spAutoFit/>
           </a:bodyPr>
           <a:lstStyle/>
@@ -6944,7 +7121,7 @@
           <a:noFill/>
         </p:spPr>
         <p:txBody>
-          <a:bodyPr wrap="square" lIns="0" rIns="0" tIns="0" bIns="0">
+          <a:bodyPr wrap="square" lIns="0" tIns="0" rIns="0" bIns="0">
             <a:spAutoFit/>
           </a:bodyPr>
           <a:lstStyle/>
@@ -7003,6 +7180,7 @@
           <a:lstStyle/>
           <a:p>
             <a:pPr algn="ctr"/>
+            <a:endParaRPr/>
           </a:p>
         </p:txBody>
       </p:sp>
@@ -7048,6 +7226,7 @@
           <a:lstStyle/>
           <a:p>
             <a:pPr algn="ctr"/>
+            <a:endParaRPr/>
           </a:p>
         </p:txBody>
       </p:sp>
@@ -7156,6 +7335,7 @@
           <a:lstStyle/>
           <a:p>
             <a:pPr algn="ctr"/>
+            <a:endParaRPr/>
           </a:p>
         </p:txBody>
       </p:sp>
@@ -7264,6 +7444,7 @@
           <a:lstStyle/>
           <a:p>
             <a:pPr algn="ctr"/>
+            <a:endParaRPr/>
           </a:p>
         </p:txBody>
       </p:sp>
@@ -7372,6 +7553,7 @@
           <a:lstStyle/>
           <a:p>
             <a:pPr algn="ctr"/>
+            <a:endParaRPr/>
           </a:p>
         </p:txBody>
       </p:sp>
@@ -7455,7 +7637,7 @@
           <a:noFill/>
         </p:spPr>
         <p:txBody>
-          <a:bodyPr wrap="none" lIns="0" rIns="0" tIns="0" bIns="0">
+          <a:bodyPr wrap="none" lIns="0" tIns="0" rIns="0" bIns="0">
             <a:spAutoFit/>
           </a:bodyPr>
           <a:lstStyle/>
@@ -7491,7 +7673,7 @@
           <a:noFill/>
         </p:spPr>
         <p:txBody>
-          <a:bodyPr wrap="none" lIns="0" rIns="0" tIns="0" bIns="0">
+          <a:bodyPr wrap="none" lIns="0" tIns="0" rIns="0" bIns="0">
             <a:spAutoFit/>
           </a:bodyPr>
           <a:lstStyle/>
@@ -7519,7 +7701,7 @@
 </file>
 
 <file path=ppt/slides/slide14.xml><?xml version="1.0" encoding="utf-8"?>
-<p:sld xmlns:a="http://schemas.openxmlformats.org/drawingml/2006/main" xmlns:p="http://schemas.openxmlformats.org/presentationml/2006/main" xmlns:r="http://schemas.openxmlformats.org/officeDocument/2006/relationships">
+<p:sld xmlns:a="http://schemas.openxmlformats.org/drawingml/2006/main" xmlns:r="http://schemas.openxmlformats.org/officeDocument/2006/relationships" xmlns:p="http://schemas.openxmlformats.org/presentationml/2006/main">
   <p:cSld>
     <p:spTree>
       <p:nvGrpSpPr>
@@ -7527,7 +7709,14 @@
         <p:cNvGrpSpPr/>
         <p:nvPr/>
       </p:nvGrpSpPr>
-      <p:grpSpPr/>
+      <p:grpSpPr>
+        <a:xfrm>
+          <a:off x="0" y="0"/>
+          <a:ext cx="0" cy="0"/>
+          <a:chOff x="0" y="0"/>
+          <a:chExt cx="0" cy="0"/>
+        </a:xfrm>
+      </p:grpSpPr>
       <p:sp>
         <p:nvSpPr>
           <p:cNvPr id="2" name="Rectangle 1"/>
@@ -7568,6 +7757,7 @@
           <a:lstStyle/>
           <a:p>
             <a:pPr algn="ctr"/>
+            <a:endParaRPr/>
           </a:p>
         </p:txBody>
       </p:sp>
@@ -7719,6 +7909,7 @@
           <a:lstStyle/>
           <a:p>
             <a:pPr algn="ctr"/>
+            <a:endParaRPr/>
           </a:p>
         </p:txBody>
       </p:sp>
@@ -7764,6 +7955,7 @@
           <a:lstStyle/>
           <a:p>
             <a:pPr algn="ctr"/>
+            <a:endParaRPr/>
           </a:p>
         </p:txBody>
       </p:sp>
@@ -7941,6 +8133,7 @@
           <a:lstStyle/>
           <a:p>
             <a:pPr algn="ctr"/>
+            <a:endParaRPr/>
           </a:p>
         </p:txBody>
       </p:sp>
@@ -8120,7 +8313,7 @@
           <a:noFill/>
         </p:spPr>
         <p:txBody>
-          <a:bodyPr wrap="none" lIns="0" rIns="0" tIns="0" bIns="0">
+          <a:bodyPr wrap="none" lIns="0" tIns="0" rIns="0" bIns="0">
             <a:spAutoFit/>
           </a:bodyPr>
           <a:lstStyle/>
@@ -8156,7 +8349,7 @@
           <a:noFill/>
         </p:spPr>
         <p:txBody>
-          <a:bodyPr wrap="none" lIns="0" rIns="0" tIns="0" bIns="0">
+          <a:bodyPr wrap="none" lIns="0" tIns="0" rIns="0" bIns="0">
             <a:spAutoFit/>
           </a:bodyPr>
           <a:lstStyle/>
@@ -8184,7 +8377,7 @@
 </file>
 
 <file path=ppt/slides/slide2.xml><?xml version="1.0" encoding="utf-8"?>
-<p:sld xmlns:a="http://schemas.openxmlformats.org/drawingml/2006/main" xmlns:p="http://schemas.openxmlformats.org/presentationml/2006/main" xmlns:r="http://schemas.openxmlformats.org/officeDocument/2006/relationships">
+<p:sld xmlns:a="http://schemas.openxmlformats.org/drawingml/2006/main" xmlns:r="http://schemas.openxmlformats.org/officeDocument/2006/relationships" xmlns:p="http://schemas.openxmlformats.org/presentationml/2006/main">
   <p:cSld>
     <p:spTree>
       <p:nvGrpSpPr>
@@ -8192,7 +8385,14 @@
         <p:cNvGrpSpPr/>
         <p:nvPr/>
       </p:nvGrpSpPr>
-      <p:grpSpPr/>
+      <p:grpSpPr>
+        <a:xfrm>
+          <a:off x="0" y="0"/>
+          <a:ext cx="0" cy="0"/>
+          <a:chOff x="0" y="0"/>
+          <a:chExt cx="0" cy="0"/>
+        </a:xfrm>
+      </p:grpSpPr>
       <p:sp>
         <p:nvSpPr>
           <p:cNvPr id="2" name="Rectangle 1"/>
@@ -8233,6 +8433,7 @@
           <a:lstStyle/>
           <a:p>
             <a:pPr algn="ctr"/>
+            <a:endParaRPr/>
           </a:p>
         </p:txBody>
       </p:sp>
@@ -8253,7 +8454,7 @@
           <a:noFill/>
         </p:spPr>
         <p:txBody>
-          <a:bodyPr wrap="square" lIns="0" rIns="0" tIns="0" bIns="0">
+          <a:bodyPr wrap="square" lIns="0" tIns="0" rIns="0" bIns="0">
             <a:spAutoFit/>
           </a:bodyPr>
           <a:lstStyle/>
@@ -8289,7 +8490,7 @@
           <a:noFill/>
         </p:spPr>
         <p:txBody>
-          <a:bodyPr wrap="square" lIns="0" rIns="0" tIns="0" bIns="0">
+          <a:bodyPr wrap="square" lIns="0" tIns="0" rIns="0" bIns="0">
             <a:spAutoFit/>
           </a:bodyPr>
           <a:lstStyle/>
@@ -8325,7 +8526,7 @@
           <a:noFill/>
         </p:spPr>
         <p:txBody>
-          <a:bodyPr wrap="square" lIns="0" rIns="0" tIns="0" bIns="0">
+          <a:bodyPr wrap="square" lIns="0" tIns="0" rIns="0" bIns="0">
             <a:spAutoFit/>
           </a:bodyPr>
           <a:lstStyle/>
@@ -8384,6 +8585,7 @@
           <a:lstStyle/>
           <a:p>
             <a:pPr algn="ctr"/>
+            <a:endParaRPr/>
           </a:p>
         </p:txBody>
       </p:sp>
@@ -8429,6 +8631,7 @@
           <a:lstStyle/>
           <a:p>
             <a:pPr algn="ctr"/>
+            <a:endParaRPr/>
           </a:p>
         </p:txBody>
       </p:sp>
@@ -8582,6 +8785,7 @@
           <a:lstStyle/>
           <a:p>
             <a:pPr algn="ctr"/>
+            <a:endParaRPr/>
           </a:p>
         </p:txBody>
       </p:sp>
@@ -8735,6 +8939,7 @@
           <a:lstStyle/>
           <a:p>
             <a:pPr algn="ctr"/>
+            <a:endParaRPr/>
           </a:p>
         </p:txBody>
       </p:sp>
@@ -8863,7 +9068,7 @@
           <a:noFill/>
         </p:spPr>
         <p:txBody>
-          <a:bodyPr wrap="none" lIns="0" rIns="0" tIns="0" bIns="0">
+          <a:bodyPr wrap="none" lIns="0" tIns="0" rIns="0" bIns="0">
             <a:spAutoFit/>
           </a:bodyPr>
           <a:lstStyle/>
@@ -8899,7 +9104,7 @@
           <a:noFill/>
         </p:spPr>
         <p:txBody>
-          <a:bodyPr wrap="none" lIns="0" rIns="0" tIns="0" bIns="0">
+          <a:bodyPr wrap="none" lIns="0" tIns="0" rIns="0" bIns="0">
             <a:spAutoFit/>
           </a:bodyPr>
           <a:lstStyle/>
@@ -8927,7 +9132,7 @@
 </file>
 
 <file path=ppt/slides/slide3.xml><?xml version="1.0" encoding="utf-8"?>
-<p:sld xmlns:a="http://schemas.openxmlformats.org/drawingml/2006/main" xmlns:p="http://schemas.openxmlformats.org/presentationml/2006/main" xmlns:r="http://schemas.openxmlformats.org/officeDocument/2006/relationships">
+<p:sld xmlns:a="http://schemas.openxmlformats.org/drawingml/2006/main" xmlns:r="http://schemas.openxmlformats.org/officeDocument/2006/relationships" xmlns:p="http://schemas.openxmlformats.org/presentationml/2006/main">
   <p:cSld>
     <p:spTree>
       <p:nvGrpSpPr>
@@ -8935,7 +9140,14 @@
         <p:cNvGrpSpPr/>
         <p:nvPr/>
       </p:nvGrpSpPr>
-      <p:grpSpPr/>
+      <p:grpSpPr>
+        <a:xfrm>
+          <a:off x="0" y="0"/>
+          <a:ext cx="0" cy="0"/>
+          <a:chOff x="0" y="0"/>
+          <a:chExt cx="0" cy="0"/>
+        </a:xfrm>
+      </p:grpSpPr>
       <p:sp>
         <p:nvSpPr>
           <p:cNvPr id="2" name="Rectangle 1"/>
@@ -8976,6 +9188,7 @@
           <a:lstStyle/>
           <a:p>
             <a:pPr algn="ctr"/>
+            <a:endParaRPr/>
           </a:p>
         </p:txBody>
       </p:sp>
@@ -8996,7 +9209,7 @@
           <a:noFill/>
         </p:spPr>
         <p:txBody>
-          <a:bodyPr wrap="square" lIns="0" rIns="0" tIns="0" bIns="0">
+          <a:bodyPr wrap="square" lIns="0" tIns="0" rIns="0" bIns="0">
             <a:spAutoFit/>
           </a:bodyPr>
           <a:lstStyle/>
@@ -9032,7 +9245,7 @@
           <a:noFill/>
         </p:spPr>
         <p:txBody>
-          <a:bodyPr wrap="square" lIns="0" rIns="0" tIns="0" bIns="0">
+          <a:bodyPr wrap="square" lIns="0" tIns="0" rIns="0" bIns="0">
             <a:spAutoFit/>
           </a:bodyPr>
           <a:lstStyle/>
@@ -9068,7 +9281,7 @@
           <a:noFill/>
         </p:spPr>
         <p:txBody>
-          <a:bodyPr wrap="square" lIns="0" rIns="0" tIns="0" bIns="0">
+          <a:bodyPr wrap="square" lIns="0" tIns="0" rIns="0" bIns="0">
             <a:spAutoFit/>
           </a:bodyPr>
           <a:lstStyle/>
@@ -9127,6 +9340,7 @@
           <a:lstStyle/>
           <a:p>
             <a:pPr algn="ctr"/>
+            <a:endParaRPr/>
           </a:p>
         </p:txBody>
       </p:sp>
@@ -9149,15 +9363,39 @@
                 <a:tableStyleId>{5C22544A-7EE6-4342-B048-85BDC9FD1C3A}</a:tableStyleId>
               </a:tblPr>
               <a:tblGrid>
-                <a:gridCol w="2194560"/>
-                <a:gridCol w="2926080"/>
-                <a:gridCol w="2651760"/>
-                <a:gridCol w="2956255"/>
+                <a:gridCol w="2194560">
+                  <a:extLst>
+                    <a:ext uri="{9D8B030D-6E8A-4147-A177-3AD203B41FA5}">
+                      <a16:colId xmlns:a16="http://schemas.microsoft.com/office/drawing/2014/main" val="20000"/>
+                    </a:ext>
+                  </a:extLst>
+                </a:gridCol>
+                <a:gridCol w="2926080">
+                  <a:extLst>
+                    <a:ext uri="{9D8B030D-6E8A-4147-A177-3AD203B41FA5}">
+                      <a16:colId xmlns:a16="http://schemas.microsoft.com/office/drawing/2014/main" val="20001"/>
+                    </a:ext>
+                  </a:extLst>
+                </a:gridCol>
+                <a:gridCol w="2651760">
+                  <a:extLst>
+                    <a:ext uri="{9D8B030D-6E8A-4147-A177-3AD203B41FA5}">
+                      <a16:colId xmlns:a16="http://schemas.microsoft.com/office/drawing/2014/main" val="20002"/>
+                    </a:ext>
+                  </a:extLst>
+                </a:gridCol>
+                <a:gridCol w="2956255">
+                  <a:extLst>
+                    <a:ext uri="{9D8B030D-6E8A-4147-A177-3AD203B41FA5}">
+                      <a16:colId xmlns:a16="http://schemas.microsoft.com/office/drawing/2014/main" val="20003"/>
+                    </a:ext>
+                  </a:extLst>
+                </a:gridCol>
               </a:tblGrid>
               <a:tr h="886968">
                 <a:tc>
                   <a:txBody>
-                    <a:bodyPr wrap="square" lIns="73152" rIns="73152" tIns="54864" bIns="54864"/>
+                    <a:bodyPr/>
                     <a:lstStyle/>
                     <a:p>
                       <a:pPr>
@@ -9181,7 +9419,7 @@
                 </a:tc>
                 <a:tc>
                   <a:txBody>
-                    <a:bodyPr wrap="square" lIns="73152" rIns="73152" tIns="54864" bIns="54864"/>
+                    <a:bodyPr/>
                     <a:lstStyle/>
                     <a:p>
                       <a:pPr>
@@ -9205,7 +9443,7 @@
                 </a:tc>
                 <a:tc>
                   <a:txBody>
-                    <a:bodyPr wrap="square" lIns="73152" rIns="73152" tIns="54864" bIns="54864"/>
+                    <a:bodyPr/>
                     <a:lstStyle/>
                     <a:p>
                       <a:pPr>
@@ -9229,7 +9467,7 @@
                 </a:tc>
                 <a:tc>
                   <a:txBody>
-                    <a:bodyPr wrap="square" lIns="73152" rIns="73152" tIns="54864" bIns="54864"/>
+                    <a:bodyPr/>
                     <a:lstStyle/>
                     <a:p>
                       <a:pPr>
@@ -9251,11 +9489,16 @@
                     </a:solidFill>
                   </a:tcPr>
                 </a:tc>
+                <a:extLst>
+                  <a:ext uri="{0D108BD9-81ED-4DB2-BD59-A6C34878D82A}">
+                    <a16:rowId xmlns:a16="http://schemas.microsoft.com/office/drawing/2014/main" val="10000"/>
+                  </a:ext>
+                </a:extLst>
               </a:tr>
               <a:tr h="886968">
                 <a:tc>
                   <a:txBody>
-                    <a:bodyPr wrap="square" lIns="73152" rIns="73152"/>
+                    <a:bodyPr/>
                     <a:lstStyle/>
                     <a:p>
                       <a:pPr>
@@ -9283,7 +9526,7 @@
                 </a:tc>
                 <a:tc>
                   <a:txBody>
-                    <a:bodyPr wrap="square" lIns="73152" rIns="73152"/>
+                    <a:bodyPr/>
                     <a:lstStyle/>
                     <a:p>
                       <a:pPr>
@@ -9307,7 +9550,7 @@
                 </a:tc>
                 <a:tc>
                   <a:txBody>
-                    <a:bodyPr wrap="square" lIns="73152" rIns="73152"/>
+                    <a:bodyPr/>
                     <a:lstStyle/>
                     <a:p>
                       <a:pPr>
@@ -9331,7 +9574,7 @@
                 </a:tc>
                 <a:tc>
                   <a:txBody>
-                    <a:bodyPr wrap="square" lIns="73152" rIns="73152"/>
+                    <a:bodyPr/>
                     <a:lstStyle/>
                     <a:p>
                       <a:pPr>
@@ -9353,11 +9596,16 @@
                     </a:solidFill>
                   </a:tcPr>
                 </a:tc>
+                <a:extLst>
+                  <a:ext uri="{0D108BD9-81ED-4DB2-BD59-A6C34878D82A}">
+                    <a16:rowId xmlns:a16="http://schemas.microsoft.com/office/drawing/2014/main" val="10001"/>
+                  </a:ext>
+                </a:extLst>
               </a:tr>
               <a:tr h="886968">
                 <a:tc>
                   <a:txBody>
-                    <a:bodyPr wrap="square" lIns="73152" rIns="73152"/>
+                    <a:bodyPr/>
                     <a:lstStyle/>
                     <a:p>
                       <a:pPr>
@@ -9385,7 +9633,7 @@
                 </a:tc>
                 <a:tc>
                   <a:txBody>
-                    <a:bodyPr wrap="square" lIns="73152" rIns="73152"/>
+                    <a:bodyPr/>
                     <a:lstStyle/>
                     <a:p>
                       <a:pPr>
@@ -9409,7 +9657,7 @@
                 </a:tc>
                 <a:tc>
                   <a:txBody>
-                    <a:bodyPr wrap="square" lIns="73152" rIns="73152"/>
+                    <a:bodyPr/>
                     <a:lstStyle/>
                     <a:p>
                       <a:pPr>
@@ -9433,7 +9681,7 @@
                 </a:tc>
                 <a:tc>
                   <a:txBody>
-                    <a:bodyPr wrap="square" lIns="73152" rIns="73152"/>
+                    <a:bodyPr/>
                     <a:lstStyle/>
                     <a:p>
                       <a:pPr>
@@ -9455,11 +9703,16 @@
                     </a:solidFill>
                   </a:tcPr>
                 </a:tc>
+                <a:extLst>
+                  <a:ext uri="{0D108BD9-81ED-4DB2-BD59-A6C34878D82A}">
+                    <a16:rowId xmlns:a16="http://schemas.microsoft.com/office/drawing/2014/main" val="10002"/>
+                  </a:ext>
+                </a:extLst>
               </a:tr>
               <a:tr h="886968">
                 <a:tc>
                   <a:txBody>
-                    <a:bodyPr wrap="square" lIns="73152" rIns="73152"/>
+                    <a:bodyPr/>
                     <a:lstStyle/>
                     <a:p>
                       <a:pPr>
@@ -9487,7 +9740,7 @@
                 </a:tc>
                 <a:tc>
                   <a:txBody>
-                    <a:bodyPr wrap="square" lIns="73152" rIns="73152"/>
+                    <a:bodyPr/>
                     <a:lstStyle/>
                     <a:p>
                       <a:pPr>
@@ -9511,7 +9764,7 @@
                 </a:tc>
                 <a:tc>
                   <a:txBody>
-                    <a:bodyPr wrap="square" lIns="73152" rIns="73152"/>
+                    <a:bodyPr/>
                     <a:lstStyle/>
                     <a:p>
                       <a:pPr>
@@ -9535,7 +9788,7 @@
                 </a:tc>
                 <a:tc>
                   <a:txBody>
-                    <a:bodyPr wrap="square" lIns="73152" rIns="73152"/>
+                    <a:bodyPr/>
                     <a:lstStyle/>
                     <a:p>
                       <a:pPr>
@@ -9557,11 +9810,16 @@
                     </a:solidFill>
                   </a:tcPr>
                 </a:tc>
+                <a:extLst>
+                  <a:ext uri="{0D108BD9-81ED-4DB2-BD59-A6C34878D82A}">
+                    <a16:rowId xmlns:a16="http://schemas.microsoft.com/office/drawing/2014/main" val="10003"/>
+                  </a:ext>
+                </a:extLst>
               </a:tr>
               <a:tr h="886968">
                 <a:tc>
                   <a:txBody>
-                    <a:bodyPr wrap="square" lIns="73152" rIns="73152"/>
+                    <a:bodyPr/>
                     <a:lstStyle/>
                     <a:p>
                       <a:pPr>
@@ -9589,7 +9847,7 @@
                 </a:tc>
                 <a:tc>
                   <a:txBody>
-                    <a:bodyPr wrap="square" lIns="73152" rIns="73152"/>
+                    <a:bodyPr/>
                     <a:lstStyle/>
                     <a:p>
                       <a:pPr>
@@ -9613,7 +9871,7 @@
                 </a:tc>
                 <a:tc>
                   <a:txBody>
-                    <a:bodyPr wrap="square" lIns="73152" rIns="73152"/>
+                    <a:bodyPr/>
                     <a:lstStyle/>
                     <a:p>
                       <a:pPr>
@@ -9637,7 +9895,7 @@
                 </a:tc>
                 <a:tc>
                   <a:txBody>
-                    <a:bodyPr wrap="square" lIns="73152" rIns="73152"/>
+                    <a:bodyPr/>
                     <a:lstStyle/>
                     <a:p>
                       <a:pPr>
@@ -9659,6 +9917,11 @@
                     </a:solidFill>
                   </a:tcPr>
                 </a:tc>
+                <a:extLst>
+                  <a:ext uri="{0D108BD9-81ED-4DB2-BD59-A6C34878D82A}">
+                    <a16:rowId xmlns:a16="http://schemas.microsoft.com/office/drawing/2014/main" val="10004"/>
+                  </a:ext>
+                </a:extLst>
               </a:tr>
             </a:tbl>
           </a:graphicData>
@@ -9681,7 +9944,7 @@
           <a:noFill/>
         </p:spPr>
         <p:txBody>
-          <a:bodyPr wrap="none" lIns="0" rIns="0" tIns="0" bIns="0">
+          <a:bodyPr wrap="none" lIns="0" tIns="0" rIns="0" bIns="0">
             <a:spAutoFit/>
           </a:bodyPr>
           <a:lstStyle/>
@@ -9717,7 +9980,7 @@
           <a:noFill/>
         </p:spPr>
         <p:txBody>
-          <a:bodyPr wrap="none" lIns="0" rIns="0" tIns="0" bIns="0">
+          <a:bodyPr wrap="none" lIns="0" tIns="0" rIns="0" bIns="0">
             <a:spAutoFit/>
           </a:bodyPr>
           <a:lstStyle/>
@@ -9745,7 +10008,7 @@
 </file>
 
 <file path=ppt/slides/slide4.xml><?xml version="1.0" encoding="utf-8"?>
-<p:sld xmlns:a="http://schemas.openxmlformats.org/drawingml/2006/main" xmlns:p="http://schemas.openxmlformats.org/presentationml/2006/main" xmlns:r="http://schemas.openxmlformats.org/officeDocument/2006/relationships">
+<p:sld xmlns:a="http://schemas.openxmlformats.org/drawingml/2006/main" xmlns:r="http://schemas.openxmlformats.org/officeDocument/2006/relationships" xmlns:p="http://schemas.openxmlformats.org/presentationml/2006/main">
   <p:cSld>
     <p:spTree>
       <p:nvGrpSpPr>
@@ -9753,7 +10016,14 @@
         <p:cNvGrpSpPr/>
         <p:nvPr/>
       </p:nvGrpSpPr>
-      <p:grpSpPr/>
+      <p:grpSpPr>
+        <a:xfrm>
+          <a:off x="0" y="0"/>
+          <a:ext cx="0" cy="0"/>
+          <a:chOff x="0" y="0"/>
+          <a:chExt cx="0" cy="0"/>
+        </a:xfrm>
+      </p:grpSpPr>
       <p:sp>
         <p:nvSpPr>
           <p:cNvPr id="2" name="Rectangle 1"/>
@@ -9794,6 +10064,7 @@
           <a:lstStyle/>
           <a:p>
             <a:pPr algn="ctr"/>
+            <a:endParaRPr/>
           </a:p>
         </p:txBody>
       </p:sp>
@@ -9814,7 +10085,7 @@
           <a:noFill/>
         </p:spPr>
         <p:txBody>
-          <a:bodyPr wrap="square" lIns="0" rIns="0" tIns="0" bIns="0">
+          <a:bodyPr wrap="square" lIns="0" tIns="0" rIns="0" bIns="0">
             <a:spAutoFit/>
           </a:bodyPr>
           <a:lstStyle/>
@@ -9850,7 +10121,7 @@
           <a:noFill/>
         </p:spPr>
         <p:txBody>
-          <a:bodyPr wrap="square" lIns="0" rIns="0" tIns="0" bIns="0">
+          <a:bodyPr wrap="square" lIns="0" tIns="0" rIns="0" bIns="0">
             <a:spAutoFit/>
           </a:bodyPr>
           <a:lstStyle/>
@@ -9886,7 +10157,7 @@
           <a:noFill/>
         </p:spPr>
         <p:txBody>
-          <a:bodyPr wrap="square" lIns="0" rIns="0" tIns="0" bIns="0">
+          <a:bodyPr wrap="square" lIns="0" tIns="0" rIns="0" bIns="0">
             <a:spAutoFit/>
           </a:bodyPr>
           <a:lstStyle/>
@@ -9945,6 +10216,7 @@
           <a:lstStyle/>
           <a:p>
             <a:pPr algn="ctr"/>
+            <a:endParaRPr/>
           </a:p>
         </p:txBody>
       </p:sp>
@@ -9990,6 +10262,7 @@
           <a:lstStyle/>
           <a:p>
             <a:pPr algn="ctr"/>
+            <a:endParaRPr/>
           </a:p>
         </p:txBody>
       </p:sp>
@@ -10111,6 +10384,7 @@
           <a:lstStyle/>
           <a:p>
             <a:pPr algn="ctr"/>
+            <a:endParaRPr/>
           </a:p>
         </p:txBody>
       </p:sp>
@@ -10232,6 +10506,7 @@
           <a:lstStyle/>
           <a:p>
             <a:pPr algn="ctr"/>
+            <a:endParaRPr/>
           </a:p>
         </p:txBody>
       </p:sp>
@@ -10353,6 +10628,7 @@
           <a:lstStyle/>
           <a:p>
             <a:pPr algn="ctr"/>
+            <a:endParaRPr/>
           </a:p>
         </p:txBody>
       </p:sp>
@@ -10449,7 +10725,7 @@
           <a:noFill/>
         </p:spPr>
         <p:txBody>
-          <a:bodyPr wrap="none" lIns="0" rIns="0" tIns="0" bIns="0">
+          <a:bodyPr wrap="none" lIns="0" tIns="0" rIns="0" bIns="0">
             <a:spAutoFit/>
           </a:bodyPr>
           <a:lstStyle/>
@@ -10485,7 +10761,7 @@
           <a:noFill/>
         </p:spPr>
         <p:txBody>
-          <a:bodyPr wrap="none" lIns="0" rIns="0" tIns="0" bIns="0">
+          <a:bodyPr wrap="none" lIns="0" tIns="0" rIns="0" bIns="0">
             <a:spAutoFit/>
           </a:bodyPr>
           <a:lstStyle/>
@@ -10513,7 +10789,7 @@
 </file>
 
 <file path=ppt/slides/slide5.xml><?xml version="1.0" encoding="utf-8"?>
-<p:sld xmlns:a="http://schemas.openxmlformats.org/drawingml/2006/main" xmlns:p="http://schemas.openxmlformats.org/presentationml/2006/main" xmlns:r="http://schemas.openxmlformats.org/officeDocument/2006/relationships">
+<p:sld xmlns:a="http://schemas.openxmlformats.org/drawingml/2006/main" xmlns:r="http://schemas.openxmlformats.org/officeDocument/2006/relationships" xmlns:p="http://schemas.openxmlformats.org/presentationml/2006/main">
   <p:cSld>
     <p:spTree>
       <p:nvGrpSpPr>
@@ -10521,7 +10797,14 @@
         <p:cNvGrpSpPr/>
         <p:nvPr/>
       </p:nvGrpSpPr>
-      <p:grpSpPr/>
+      <p:grpSpPr>
+        <a:xfrm>
+          <a:off x="0" y="0"/>
+          <a:ext cx="0" cy="0"/>
+          <a:chOff x="0" y="0"/>
+          <a:chExt cx="0" cy="0"/>
+        </a:xfrm>
+      </p:grpSpPr>
       <p:sp>
         <p:nvSpPr>
           <p:cNvPr id="2" name="Rectangle 1"/>
@@ -10562,6 +10845,7 @@
           <a:lstStyle/>
           <a:p>
             <a:pPr algn="ctr"/>
+            <a:endParaRPr/>
           </a:p>
         </p:txBody>
       </p:sp>
@@ -10582,7 +10866,7 @@
           <a:noFill/>
         </p:spPr>
         <p:txBody>
-          <a:bodyPr wrap="square" lIns="0" rIns="0" tIns="0" bIns="0">
+          <a:bodyPr wrap="square" lIns="0" tIns="0" rIns="0" bIns="0">
             <a:spAutoFit/>
           </a:bodyPr>
           <a:lstStyle/>
@@ -10618,7 +10902,7 @@
           <a:noFill/>
         </p:spPr>
         <p:txBody>
-          <a:bodyPr wrap="square" lIns="0" rIns="0" tIns="0" bIns="0">
+          <a:bodyPr wrap="square" lIns="0" tIns="0" rIns="0" bIns="0">
             <a:spAutoFit/>
           </a:bodyPr>
           <a:lstStyle/>
@@ -10654,7 +10938,7 @@
           <a:noFill/>
         </p:spPr>
         <p:txBody>
-          <a:bodyPr wrap="square" lIns="0" rIns="0" tIns="0" bIns="0">
+          <a:bodyPr wrap="square" lIns="0" tIns="0" rIns="0" bIns="0">
             <a:spAutoFit/>
           </a:bodyPr>
           <a:lstStyle/>
@@ -10713,6 +10997,7 @@
           <a:lstStyle/>
           <a:p>
             <a:pPr algn="ctr"/>
+            <a:endParaRPr/>
           </a:p>
         </p:txBody>
       </p:sp>
@@ -10758,6 +11043,7 @@
           <a:lstStyle/>
           <a:p>
             <a:pPr algn="ctr"/>
+            <a:endParaRPr/>
           </a:p>
         </p:txBody>
       </p:sp>
@@ -10851,6 +11137,7 @@
           <a:lstStyle/>
           <a:p>
             <a:pPr algn="ctr"/>
+            <a:endParaRPr/>
           </a:p>
         </p:txBody>
       </p:sp>
@@ -10944,6 +11231,7 @@
           <a:lstStyle/>
           <a:p>
             <a:pPr algn="ctr"/>
+            <a:endParaRPr/>
           </a:p>
         </p:txBody>
       </p:sp>
@@ -11037,6 +11325,7 @@
           <a:lstStyle/>
           <a:p>
             <a:pPr algn="ctr"/>
+            <a:endParaRPr/>
           </a:p>
         </p:txBody>
       </p:sp>
@@ -11130,6 +11419,7 @@
           <a:lstStyle/>
           <a:p>
             <a:pPr algn="ctr"/>
+            <a:endParaRPr/>
           </a:p>
         </p:txBody>
       </p:sp>
@@ -11223,6 +11513,7 @@
           <a:lstStyle/>
           <a:p>
             <a:pPr algn="ctr"/>
+            <a:endParaRPr/>
           </a:p>
         </p:txBody>
       </p:sp>
@@ -11316,6 +11607,7 @@
           <a:lstStyle/>
           <a:p>
             <a:pPr algn="ctr"/>
+            <a:endParaRPr/>
           </a:p>
         </p:txBody>
       </p:sp>
@@ -11409,6 +11701,7 @@
           <a:lstStyle/>
           <a:p>
             <a:pPr algn="ctr"/>
+            <a:endParaRPr/>
           </a:p>
         </p:txBody>
       </p:sp>
@@ -11477,7 +11770,7 @@
           <a:noFill/>
         </p:spPr>
         <p:txBody>
-          <a:bodyPr wrap="none" lIns="0" rIns="0" tIns="0" bIns="0">
+          <a:bodyPr wrap="none" lIns="0" tIns="0" rIns="0" bIns="0">
             <a:spAutoFit/>
           </a:bodyPr>
           <a:lstStyle/>
@@ -11513,7 +11806,7 @@
           <a:noFill/>
         </p:spPr>
         <p:txBody>
-          <a:bodyPr wrap="none" lIns="0" rIns="0" tIns="0" bIns="0">
+          <a:bodyPr wrap="none" lIns="0" tIns="0" rIns="0" bIns="0">
             <a:spAutoFit/>
           </a:bodyPr>
           <a:lstStyle/>
@@ -11541,7 +11834,7 @@
 </file>
 
 <file path=ppt/slides/slide6.xml><?xml version="1.0" encoding="utf-8"?>
-<p:sld xmlns:a="http://schemas.openxmlformats.org/drawingml/2006/main" xmlns:p="http://schemas.openxmlformats.org/presentationml/2006/main" xmlns:r="http://schemas.openxmlformats.org/officeDocument/2006/relationships">
+<p:sld xmlns:a="http://schemas.openxmlformats.org/drawingml/2006/main" xmlns:r="http://schemas.openxmlformats.org/officeDocument/2006/relationships" xmlns:p="http://schemas.openxmlformats.org/presentationml/2006/main">
   <p:cSld>
     <p:spTree>
       <p:nvGrpSpPr>
@@ -11549,7 +11842,14 @@
         <p:cNvGrpSpPr/>
         <p:nvPr/>
       </p:nvGrpSpPr>
-      <p:grpSpPr/>
+      <p:grpSpPr>
+        <a:xfrm>
+          <a:off x="0" y="0"/>
+          <a:ext cx="0" cy="0"/>
+          <a:chOff x="0" y="0"/>
+          <a:chExt cx="0" cy="0"/>
+        </a:xfrm>
+      </p:grpSpPr>
       <p:sp>
         <p:nvSpPr>
           <p:cNvPr id="2" name="Rectangle 1"/>
@@ -11590,6 +11890,7 @@
           <a:lstStyle/>
           <a:p>
             <a:pPr algn="ctr"/>
+            <a:endParaRPr/>
           </a:p>
         </p:txBody>
       </p:sp>
@@ -11610,7 +11911,7 @@
           <a:noFill/>
         </p:spPr>
         <p:txBody>
-          <a:bodyPr wrap="square" lIns="0" rIns="0" tIns="0" bIns="0">
+          <a:bodyPr wrap="square" lIns="0" tIns="0" rIns="0" bIns="0">
             <a:spAutoFit/>
           </a:bodyPr>
           <a:lstStyle/>
@@ -11646,7 +11947,7 @@
           <a:noFill/>
         </p:spPr>
         <p:txBody>
-          <a:bodyPr wrap="square" lIns="0" rIns="0" tIns="0" bIns="0">
+          <a:bodyPr wrap="square" lIns="0" tIns="0" rIns="0" bIns="0">
             <a:spAutoFit/>
           </a:bodyPr>
           <a:lstStyle/>
@@ -11682,7 +11983,7 @@
           <a:noFill/>
         </p:spPr>
         <p:txBody>
-          <a:bodyPr wrap="square" lIns="0" rIns="0" tIns="0" bIns="0">
+          <a:bodyPr wrap="square" lIns="0" tIns="0" rIns="0" bIns="0">
             <a:spAutoFit/>
           </a:bodyPr>
           <a:lstStyle/>
@@ -11741,6 +12042,7 @@
           <a:lstStyle/>
           <a:p>
             <a:pPr algn="ctr"/>
+            <a:endParaRPr/>
           </a:p>
         </p:txBody>
       </p:sp>
@@ -11786,6 +12088,7 @@
           <a:lstStyle/>
           <a:p>
             <a:pPr algn="ctr"/>
+            <a:endParaRPr/>
           </a:p>
         </p:txBody>
       </p:sp>
@@ -11987,6 +12290,7 @@
           <a:lstStyle/>
           <a:p>
             <a:pPr algn="ctr"/>
+            <a:endParaRPr/>
           </a:p>
         </p:txBody>
       </p:sp>
@@ -12139,7 +12443,7 @@
           <a:noFill/>
         </p:spPr>
         <p:txBody>
-          <a:bodyPr wrap="none" lIns="0" rIns="0" tIns="0" bIns="0">
+          <a:bodyPr wrap="none" lIns="0" tIns="0" rIns="0" bIns="0">
             <a:spAutoFit/>
           </a:bodyPr>
           <a:lstStyle/>
@@ -12175,7 +12479,7 @@
           <a:noFill/>
         </p:spPr>
         <p:txBody>
-          <a:bodyPr wrap="none" lIns="0" rIns="0" tIns="0" bIns="0">
+          <a:bodyPr wrap="none" lIns="0" tIns="0" rIns="0" bIns="0">
             <a:spAutoFit/>
           </a:bodyPr>
           <a:lstStyle/>
@@ -12203,7 +12507,7 @@
 </file>
 
 <file path=ppt/slides/slide7.xml><?xml version="1.0" encoding="utf-8"?>
-<p:sld xmlns:a="http://schemas.openxmlformats.org/drawingml/2006/main" xmlns:p="http://schemas.openxmlformats.org/presentationml/2006/main" xmlns:r="http://schemas.openxmlformats.org/officeDocument/2006/relationships">
+<p:sld xmlns:a="http://schemas.openxmlformats.org/drawingml/2006/main" xmlns:r="http://schemas.openxmlformats.org/officeDocument/2006/relationships" xmlns:p="http://schemas.openxmlformats.org/presentationml/2006/main">
   <p:cSld>
     <p:spTree>
       <p:nvGrpSpPr>
@@ -12211,7 +12515,14 @@
         <p:cNvGrpSpPr/>
         <p:nvPr/>
       </p:nvGrpSpPr>
-      <p:grpSpPr/>
+      <p:grpSpPr>
+        <a:xfrm>
+          <a:off x="0" y="0"/>
+          <a:ext cx="0" cy="0"/>
+          <a:chOff x="0" y="0"/>
+          <a:chExt cx="0" cy="0"/>
+        </a:xfrm>
+      </p:grpSpPr>
       <p:sp>
         <p:nvSpPr>
           <p:cNvPr id="2" name="Rectangle 1"/>
@@ -12252,6 +12563,7 @@
           <a:lstStyle/>
           <a:p>
             <a:pPr algn="ctr"/>
+            <a:endParaRPr/>
           </a:p>
         </p:txBody>
       </p:sp>
@@ -12272,7 +12584,7 @@
           <a:noFill/>
         </p:spPr>
         <p:txBody>
-          <a:bodyPr wrap="square" lIns="0" rIns="0" tIns="0" bIns="0">
+          <a:bodyPr wrap="square" lIns="0" tIns="0" rIns="0" bIns="0">
             <a:spAutoFit/>
           </a:bodyPr>
           <a:lstStyle/>
@@ -12308,7 +12620,7 @@
           <a:noFill/>
         </p:spPr>
         <p:txBody>
-          <a:bodyPr wrap="square" lIns="0" rIns="0" tIns="0" bIns="0">
+          <a:bodyPr wrap="square" lIns="0" tIns="0" rIns="0" bIns="0">
             <a:spAutoFit/>
           </a:bodyPr>
           <a:lstStyle/>
@@ -12344,7 +12656,7 @@
           <a:noFill/>
         </p:spPr>
         <p:txBody>
-          <a:bodyPr wrap="square" lIns="0" rIns="0" tIns="0" bIns="0">
+          <a:bodyPr wrap="square" lIns="0" tIns="0" rIns="0" bIns="0">
             <a:spAutoFit/>
           </a:bodyPr>
           <a:lstStyle/>
@@ -12403,6 +12715,7 @@
           <a:lstStyle/>
           <a:p>
             <a:pPr algn="ctr"/>
+            <a:endParaRPr/>
           </a:p>
         </p:txBody>
       </p:sp>
@@ -12448,6 +12761,7 @@
           <a:lstStyle/>
           <a:p>
             <a:pPr algn="ctr"/>
+            <a:endParaRPr/>
           </a:p>
         </p:txBody>
       </p:sp>
@@ -12721,6 +13035,7 @@
           <a:lstStyle/>
           <a:p>
             <a:pPr algn="ctr"/>
+            <a:endParaRPr/>
           </a:p>
         </p:txBody>
       </p:sp>
@@ -12765,7 +13080,7 @@
               </a:spcBef>
             </a:pPr>
             <a:r>
-              <a:rPr b="1" sz="1000">
+              <a:rPr sz="1000" b="1">
                 <a:solidFill>
                   <a:srgbClr val="35423E"/>
                 </a:solidFill>
@@ -12773,7 +13088,7 @@
               <a:t>Groundedness Score: </a:t>
             </a:r>
             <a:r>
-              <a:rPr b="1" sz="1100">
+              <a:rPr sz="1100" b="1">
                 <a:solidFill>
                   <a:srgbClr val="2D553C"/>
                 </a:solidFill>
@@ -12797,7 +13112,7 @@
               </a:spcBef>
             </a:pPr>
             <a:r>
-              <a:rPr b="1" sz="1000">
+              <a:rPr sz="1000" b="1">
                 <a:solidFill>
                   <a:srgbClr val="35423E"/>
                 </a:solidFill>
@@ -12805,7 +13120,7 @@
               <a:t>Citation Coverage: </a:t>
             </a:r>
             <a:r>
-              <a:rPr b="1" sz="1100">
+              <a:rPr sz="1100" b="1">
                 <a:solidFill>
                   <a:srgbClr val="2D553C"/>
                 </a:solidFill>
@@ -12829,7 +13144,7 @@
               </a:spcBef>
             </a:pPr>
             <a:r>
-              <a:rPr b="1" sz="1000">
+              <a:rPr sz="1000" b="1">
                 <a:solidFill>
                   <a:srgbClr val="35423E"/>
                 </a:solidFill>
@@ -12837,7 +13152,7 @@
               <a:t>Evidence Match: </a:t>
             </a:r>
             <a:r>
-              <a:rPr b="1" sz="1100">
+              <a:rPr sz="1100" b="1">
                 <a:solidFill>
                   <a:srgbClr val="2D553C"/>
                 </a:solidFill>
@@ -12861,7 +13176,7 @@
               </a:spcBef>
             </a:pPr>
             <a:r>
-              <a:rPr b="1" sz="1000">
+              <a:rPr sz="1000" b="1">
                 <a:solidFill>
                   <a:srgbClr val="35423E"/>
                 </a:solidFill>
@@ -12869,7 +13184,7 @@
               <a:t>Source Reliability Index: </a:t>
             </a:r>
             <a:r>
-              <a:rPr b="1" sz="1100">
+              <a:rPr sz="1100" b="1">
                 <a:solidFill>
                   <a:srgbClr val="2D553C"/>
                 </a:solidFill>
@@ -12905,7 +13220,7 @@
           <a:noFill/>
         </p:spPr>
         <p:txBody>
-          <a:bodyPr wrap="none" lIns="0" rIns="0" tIns="0" bIns="0">
+          <a:bodyPr wrap="none" lIns="0" tIns="0" rIns="0" bIns="0">
             <a:spAutoFit/>
           </a:bodyPr>
           <a:lstStyle/>
@@ -12941,7 +13256,7 @@
           <a:noFill/>
         </p:spPr>
         <p:txBody>
-          <a:bodyPr wrap="none" lIns="0" rIns="0" tIns="0" bIns="0">
+          <a:bodyPr wrap="none" lIns="0" tIns="0" rIns="0" bIns="0">
             <a:spAutoFit/>
           </a:bodyPr>
           <a:lstStyle/>
@@ -12969,7 +13284,7 @@
 </file>
 
 <file path=ppt/slides/slide8.xml><?xml version="1.0" encoding="utf-8"?>
-<p:sld xmlns:a="http://schemas.openxmlformats.org/drawingml/2006/main" xmlns:p="http://schemas.openxmlformats.org/presentationml/2006/main" xmlns:r="http://schemas.openxmlformats.org/officeDocument/2006/relationships">
+<p:sld xmlns:a="http://schemas.openxmlformats.org/drawingml/2006/main" xmlns:r="http://schemas.openxmlformats.org/officeDocument/2006/relationships" xmlns:p="http://schemas.openxmlformats.org/presentationml/2006/main">
   <p:cSld>
     <p:spTree>
       <p:nvGrpSpPr>
@@ -12977,7 +13292,14 @@
         <p:cNvGrpSpPr/>
         <p:nvPr/>
       </p:nvGrpSpPr>
-      <p:grpSpPr/>
+      <p:grpSpPr>
+        <a:xfrm>
+          <a:off x="0" y="0"/>
+          <a:ext cx="0" cy="0"/>
+          <a:chOff x="0" y="0"/>
+          <a:chExt cx="0" cy="0"/>
+        </a:xfrm>
+      </p:grpSpPr>
       <p:sp>
         <p:nvSpPr>
           <p:cNvPr id="2" name="Rectangle 1"/>
@@ -13018,6 +13340,7 @@
           <a:lstStyle/>
           <a:p>
             <a:pPr algn="ctr"/>
+            <a:endParaRPr/>
           </a:p>
         </p:txBody>
       </p:sp>
@@ -13038,7 +13361,7 @@
           <a:noFill/>
         </p:spPr>
         <p:txBody>
-          <a:bodyPr wrap="square" lIns="0" rIns="0" tIns="0" bIns="0">
+          <a:bodyPr wrap="square" lIns="0" tIns="0" rIns="0" bIns="0">
             <a:spAutoFit/>
           </a:bodyPr>
           <a:lstStyle/>
@@ -13074,7 +13397,7 @@
           <a:noFill/>
         </p:spPr>
         <p:txBody>
-          <a:bodyPr wrap="square" lIns="0" rIns="0" tIns="0" bIns="0">
+          <a:bodyPr wrap="square" lIns="0" tIns="0" rIns="0" bIns="0">
             <a:spAutoFit/>
           </a:bodyPr>
           <a:lstStyle/>
@@ -13110,7 +13433,7 @@
           <a:noFill/>
         </p:spPr>
         <p:txBody>
-          <a:bodyPr wrap="square" lIns="0" rIns="0" tIns="0" bIns="0">
+          <a:bodyPr wrap="square" lIns="0" tIns="0" rIns="0" bIns="0">
             <a:spAutoFit/>
           </a:bodyPr>
           <a:lstStyle/>
@@ -13169,6 +13492,7 @@
           <a:lstStyle/>
           <a:p>
             <a:pPr algn="ctr"/>
+            <a:endParaRPr/>
           </a:p>
         </p:txBody>
       </p:sp>
@@ -13214,6 +13538,7 @@
           <a:lstStyle/>
           <a:p>
             <a:pPr algn="ctr"/>
+            <a:endParaRPr/>
           </a:p>
         </p:txBody>
       </p:sp>
@@ -13346,6 +13671,7 @@
           <a:lstStyle/>
           <a:p>
             <a:pPr algn="ctr"/>
+            <a:endParaRPr/>
           </a:p>
         </p:txBody>
       </p:sp>
@@ -13479,6 +13805,7 @@
           <a:lstStyle/>
           <a:p>
             <a:pPr algn="ctr"/>
+            <a:endParaRPr/>
           </a:p>
         </p:txBody>
       </p:sp>
@@ -13583,7 +13910,7 @@
           <a:noFill/>
         </p:spPr>
         <p:txBody>
-          <a:bodyPr wrap="none" lIns="0" rIns="0" tIns="0" bIns="0">
+          <a:bodyPr wrap="none" lIns="0" tIns="0" rIns="0" bIns="0">
             <a:spAutoFit/>
           </a:bodyPr>
           <a:lstStyle/>
@@ -13619,7 +13946,7 @@
           <a:noFill/>
         </p:spPr>
         <p:txBody>
-          <a:bodyPr wrap="none" lIns="0" rIns="0" tIns="0" bIns="0">
+          <a:bodyPr wrap="none" lIns="0" tIns="0" rIns="0" bIns="0">
             <a:spAutoFit/>
           </a:bodyPr>
           <a:lstStyle/>
@@ -13647,7 +13974,7 @@
 </file>
 
 <file path=ppt/slides/slide9.xml><?xml version="1.0" encoding="utf-8"?>
-<p:sld xmlns:a="http://schemas.openxmlformats.org/drawingml/2006/main" xmlns:p="http://schemas.openxmlformats.org/presentationml/2006/main" xmlns:r="http://schemas.openxmlformats.org/officeDocument/2006/relationships">
+<p:sld xmlns:a="http://schemas.openxmlformats.org/drawingml/2006/main" xmlns:r="http://schemas.openxmlformats.org/officeDocument/2006/relationships" xmlns:p="http://schemas.openxmlformats.org/presentationml/2006/main">
   <p:cSld>
     <p:spTree>
       <p:nvGrpSpPr>
@@ -13655,7 +13982,14 @@
         <p:cNvGrpSpPr/>
         <p:nvPr/>
       </p:nvGrpSpPr>
-      <p:grpSpPr/>
+      <p:grpSpPr>
+        <a:xfrm>
+          <a:off x="0" y="0"/>
+          <a:ext cx="0" cy="0"/>
+          <a:chOff x="0" y="0"/>
+          <a:chExt cx="0" cy="0"/>
+        </a:xfrm>
+      </p:grpSpPr>
       <p:sp>
         <p:nvSpPr>
           <p:cNvPr id="2" name="Rectangle 1"/>
@@ -13696,6 +14030,7 @@
           <a:lstStyle/>
           <a:p>
             <a:pPr algn="ctr"/>
+            <a:endParaRPr/>
           </a:p>
         </p:txBody>
       </p:sp>
@@ -13716,7 +14051,7 @@
           <a:noFill/>
         </p:spPr>
         <p:txBody>
-          <a:bodyPr wrap="square" lIns="0" rIns="0" tIns="0" bIns="0">
+          <a:bodyPr wrap="square" lIns="0" tIns="0" rIns="0" bIns="0">
             <a:spAutoFit/>
           </a:bodyPr>
           <a:lstStyle/>
@@ -13752,7 +14087,7 @@
           <a:noFill/>
         </p:spPr>
         <p:txBody>
-          <a:bodyPr wrap="square" lIns="0" rIns="0" tIns="0" bIns="0">
+          <a:bodyPr wrap="square" lIns="0" tIns="0" rIns="0" bIns="0">
             <a:spAutoFit/>
           </a:bodyPr>
           <a:lstStyle/>
@@ -13788,7 +14123,7 @@
           <a:noFill/>
         </p:spPr>
         <p:txBody>
-          <a:bodyPr wrap="square" lIns="0" rIns="0" tIns="0" bIns="0">
+          <a:bodyPr wrap="square" lIns="0" tIns="0" rIns="0" bIns="0">
             <a:spAutoFit/>
           </a:bodyPr>
           <a:lstStyle/>
@@ -13847,6 +14182,7 @@
           <a:lstStyle/>
           <a:p>
             <a:pPr algn="ctr"/>
+            <a:endParaRPr/>
           </a:p>
         </p:txBody>
       </p:sp>
@@ -13869,16 +14205,46 @@
                 <a:tableStyleId>{5C22544A-7EE6-4342-B048-85BDC9FD1C3A}</a:tableStyleId>
               </a:tblPr>
               <a:tblGrid>
-                <a:gridCol w="2011680"/>
-                <a:gridCol w="3108960"/>
-                <a:gridCol w="1280160"/>
-                <a:gridCol w="3291840"/>
-                <a:gridCol w="1036015"/>
+                <a:gridCol w="2011680">
+                  <a:extLst>
+                    <a:ext uri="{9D8B030D-6E8A-4147-A177-3AD203B41FA5}">
+                      <a16:colId xmlns:a16="http://schemas.microsoft.com/office/drawing/2014/main" val="20000"/>
+                    </a:ext>
+                  </a:extLst>
+                </a:gridCol>
+                <a:gridCol w="3108960">
+                  <a:extLst>
+                    <a:ext uri="{9D8B030D-6E8A-4147-A177-3AD203B41FA5}">
+                      <a16:colId xmlns:a16="http://schemas.microsoft.com/office/drawing/2014/main" val="20001"/>
+                    </a:ext>
+                  </a:extLst>
+                </a:gridCol>
+                <a:gridCol w="1280160">
+                  <a:extLst>
+                    <a:ext uri="{9D8B030D-6E8A-4147-A177-3AD203B41FA5}">
+                      <a16:colId xmlns:a16="http://schemas.microsoft.com/office/drawing/2014/main" val="20002"/>
+                    </a:ext>
+                  </a:extLst>
+                </a:gridCol>
+                <a:gridCol w="3291840">
+                  <a:extLst>
+                    <a:ext uri="{9D8B030D-6E8A-4147-A177-3AD203B41FA5}">
+                      <a16:colId xmlns:a16="http://schemas.microsoft.com/office/drawing/2014/main" val="20003"/>
+                    </a:ext>
+                  </a:extLst>
+                </a:gridCol>
+                <a:gridCol w="1036015">
+                  <a:extLst>
+                    <a:ext uri="{9D8B030D-6E8A-4147-A177-3AD203B41FA5}">
+                      <a16:colId xmlns:a16="http://schemas.microsoft.com/office/drawing/2014/main" val="20004"/>
+                    </a:ext>
+                  </a:extLst>
+                </a:gridCol>
               </a:tblGrid>
               <a:tr h="633548">
                 <a:tc>
                   <a:txBody>
-                    <a:bodyPr wrap="square" lIns="73152" rIns="73152" tIns="54864" bIns="54864"/>
+                    <a:bodyPr/>
                     <a:lstStyle/>
                     <a:p>
                       <a:pPr>
@@ -13902,7 +14268,7 @@
                 </a:tc>
                 <a:tc>
                   <a:txBody>
-                    <a:bodyPr wrap="square" lIns="73152" rIns="73152" tIns="54864" bIns="54864"/>
+                    <a:bodyPr/>
                     <a:lstStyle/>
                     <a:p>
                       <a:pPr>
@@ -13926,7 +14292,7 @@
                 </a:tc>
                 <a:tc>
                   <a:txBody>
-                    <a:bodyPr wrap="square" lIns="73152" rIns="73152" tIns="54864" bIns="54864"/>
+                    <a:bodyPr/>
                     <a:lstStyle/>
                     <a:p>
                       <a:pPr>
@@ -13950,7 +14316,7 @@
                 </a:tc>
                 <a:tc>
                   <a:txBody>
-                    <a:bodyPr wrap="square" lIns="73152" rIns="73152" tIns="54864" bIns="54864"/>
+                    <a:bodyPr/>
                     <a:lstStyle/>
                     <a:p>
                       <a:pPr>
@@ -13974,7 +14340,7 @@
                 </a:tc>
                 <a:tc>
                   <a:txBody>
-                    <a:bodyPr wrap="square" lIns="73152" rIns="73152" tIns="54864" bIns="54864"/>
+                    <a:bodyPr/>
                     <a:lstStyle/>
                     <a:p>
                       <a:pPr>
@@ -13996,11 +14362,16 @@
                     </a:solidFill>
                   </a:tcPr>
                 </a:tc>
+                <a:extLst>
+                  <a:ext uri="{0D108BD9-81ED-4DB2-BD59-A6C34878D82A}">
+                    <a16:rowId xmlns:a16="http://schemas.microsoft.com/office/drawing/2014/main" val="10000"/>
+                  </a:ext>
+                </a:extLst>
               </a:tr>
               <a:tr h="633548">
                 <a:tc>
                   <a:txBody>
-                    <a:bodyPr wrap="square" lIns="73152" rIns="73152"/>
+                    <a:bodyPr/>
                     <a:lstStyle/>
                     <a:p>
                       <a:pPr>
@@ -14028,7 +14399,7 @@
                 </a:tc>
                 <a:tc>
                   <a:txBody>
-                    <a:bodyPr wrap="square" lIns="73152" rIns="73152"/>
+                    <a:bodyPr/>
                     <a:lstStyle/>
                     <a:p>
                       <a:pPr>
@@ -14052,7 +14423,7 @@
                 </a:tc>
                 <a:tc>
                   <a:txBody>
-                    <a:bodyPr wrap="square" lIns="73152" rIns="73152"/>
+                    <a:bodyPr/>
                     <a:lstStyle/>
                     <a:p>
                       <a:pPr>
@@ -14080,7 +14451,7 @@
                 </a:tc>
                 <a:tc>
                   <a:txBody>
-                    <a:bodyPr wrap="square" lIns="73152" rIns="73152"/>
+                    <a:bodyPr/>
                     <a:lstStyle/>
                     <a:p>
                       <a:pPr>
@@ -14108,7 +14479,7 @@
                 </a:tc>
                 <a:tc>
                   <a:txBody>
-                    <a:bodyPr wrap="square" lIns="73152" rIns="73152"/>
+                    <a:bodyPr/>
                     <a:lstStyle/>
                     <a:p>
                       <a:pPr>
@@ -14130,11 +14501,16 @@
                     </a:solidFill>
                   </a:tcPr>
                 </a:tc>
+                <a:extLst>
+                  <a:ext uri="{0D108BD9-81ED-4DB2-BD59-A6C34878D82A}">
+                    <a16:rowId xmlns:a16="http://schemas.microsoft.com/office/drawing/2014/main" val="10001"/>
+                  </a:ext>
+                </a:extLst>
               </a:tr>
               <a:tr h="633548">
                 <a:tc>
                   <a:txBody>
-                    <a:bodyPr wrap="square" lIns="73152" rIns="73152"/>
+                    <a:bodyPr/>
                     <a:lstStyle/>
                     <a:p>
                       <a:pPr>
@@ -14162,7 +14538,7 @@
                 </a:tc>
                 <a:tc>
                   <a:txBody>
-                    <a:bodyPr wrap="square" lIns="73152" rIns="73152"/>
+                    <a:bodyPr/>
                     <a:lstStyle/>
                     <a:p>
                       <a:pPr>
@@ -14186,7 +14562,7 @@
                 </a:tc>
                 <a:tc>
                   <a:txBody>
-                    <a:bodyPr wrap="square" lIns="73152" rIns="73152"/>
+                    <a:bodyPr/>
                     <a:lstStyle/>
                     <a:p>
                       <a:pPr>
@@ -14214,7 +14590,7 @@
                 </a:tc>
                 <a:tc>
                   <a:txBody>
-                    <a:bodyPr wrap="square" lIns="73152" rIns="73152"/>
+                    <a:bodyPr/>
                     <a:lstStyle/>
                     <a:p>
                       <a:pPr>
@@ -14242,7 +14618,7 @@
                 </a:tc>
                 <a:tc>
                   <a:txBody>
-                    <a:bodyPr wrap="square" lIns="73152" rIns="73152"/>
+                    <a:bodyPr/>
                     <a:lstStyle/>
                     <a:p>
                       <a:pPr>
@@ -14264,11 +14640,16 @@
                     </a:solidFill>
                   </a:tcPr>
                 </a:tc>
+                <a:extLst>
+                  <a:ext uri="{0D108BD9-81ED-4DB2-BD59-A6C34878D82A}">
+                    <a16:rowId xmlns:a16="http://schemas.microsoft.com/office/drawing/2014/main" val="10002"/>
+                  </a:ext>
+                </a:extLst>
               </a:tr>
               <a:tr h="633548">
                 <a:tc>
                   <a:txBody>
-                    <a:bodyPr wrap="square" lIns="73152" rIns="73152"/>
+                    <a:bodyPr/>
                     <a:lstStyle/>
                     <a:p>
                       <a:pPr>
@@ -14296,7 +14677,7 @@
                 </a:tc>
                 <a:tc>
                   <a:txBody>
-                    <a:bodyPr wrap="square" lIns="73152" rIns="73152"/>
+                    <a:bodyPr/>
                     <a:lstStyle/>
                     <a:p>
                       <a:pPr>
@@ -14320,7 +14701,7 @@
                 </a:tc>
                 <a:tc>
                   <a:txBody>
-                    <a:bodyPr wrap="square" lIns="73152" rIns="73152"/>
+                    <a:bodyPr/>
                     <a:lstStyle/>
                     <a:p>
                       <a:pPr>
@@ -14348,7 +14729,7 @@
                 </a:tc>
                 <a:tc>
                   <a:txBody>
-                    <a:bodyPr wrap="square" lIns="73152" rIns="73152"/>
+                    <a:bodyPr/>
                     <a:lstStyle/>
                     <a:p>
                       <a:pPr>
@@ -14376,7 +14757,7 @@
                 </a:tc>
                 <a:tc>
                   <a:txBody>
-                    <a:bodyPr wrap="square" lIns="73152" rIns="73152"/>
+                    <a:bodyPr/>
                     <a:lstStyle/>
                     <a:p>
                       <a:pPr>
@@ -14398,11 +14779,16 @@
                     </a:solidFill>
                   </a:tcPr>
                 </a:tc>
+                <a:extLst>
+                  <a:ext uri="{0D108BD9-81ED-4DB2-BD59-A6C34878D82A}">
+                    <a16:rowId xmlns:a16="http://schemas.microsoft.com/office/drawing/2014/main" val="10003"/>
+                  </a:ext>
+                </a:extLst>
               </a:tr>
               <a:tr h="633548">
                 <a:tc>
                   <a:txBody>
-                    <a:bodyPr wrap="square" lIns="73152" rIns="73152"/>
+                    <a:bodyPr/>
                     <a:lstStyle/>
                     <a:p>
                       <a:pPr>
@@ -14430,7 +14816,7 @@
                 </a:tc>
                 <a:tc>
                   <a:txBody>
-                    <a:bodyPr wrap="square" lIns="73152" rIns="73152"/>
+                    <a:bodyPr/>
                     <a:lstStyle/>
                     <a:p>
                       <a:pPr>
@@ -14454,7 +14840,7 @@
                 </a:tc>
                 <a:tc>
                   <a:txBody>
-                    <a:bodyPr wrap="square" lIns="73152" rIns="73152"/>
+                    <a:bodyPr/>
                     <a:lstStyle/>
                     <a:p>
                       <a:pPr>
@@ -14482,7 +14868,7 @@
                 </a:tc>
                 <a:tc>
                   <a:txBody>
-                    <a:bodyPr wrap="square" lIns="73152" rIns="73152"/>
+                    <a:bodyPr/>
                     <a:lstStyle/>
                     <a:p>
                       <a:pPr>
@@ -14510,7 +14896,7 @@
                 </a:tc>
                 <a:tc>
                   <a:txBody>
-                    <a:bodyPr wrap="square" lIns="73152" rIns="73152"/>
+                    <a:bodyPr/>
                     <a:lstStyle/>
                     <a:p>
                       <a:pPr>
@@ -14532,11 +14918,16 @@
                     </a:solidFill>
                   </a:tcPr>
                 </a:tc>
+                <a:extLst>
+                  <a:ext uri="{0D108BD9-81ED-4DB2-BD59-A6C34878D82A}">
+                    <a16:rowId xmlns:a16="http://schemas.microsoft.com/office/drawing/2014/main" val="10004"/>
+                  </a:ext>
+                </a:extLst>
               </a:tr>
               <a:tr h="633548">
                 <a:tc>
                   <a:txBody>
-                    <a:bodyPr wrap="square" lIns="73152" rIns="73152"/>
+                    <a:bodyPr/>
                     <a:lstStyle/>
                     <a:p>
                       <a:pPr>
@@ -14564,7 +14955,7 @@
                 </a:tc>
                 <a:tc>
                   <a:txBody>
-                    <a:bodyPr wrap="square" lIns="73152" rIns="73152"/>
+                    <a:bodyPr/>
                     <a:lstStyle/>
                     <a:p>
                       <a:pPr>
@@ -14588,7 +14979,7 @@
                 </a:tc>
                 <a:tc>
                   <a:txBody>
-                    <a:bodyPr wrap="square" lIns="73152" rIns="73152"/>
+                    <a:bodyPr/>
                     <a:lstStyle/>
                     <a:p>
                       <a:pPr>
@@ -14616,7 +15007,7 @@
                 </a:tc>
                 <a:tc>
                   <a:txBody>
-                    <a:bodyPr wrap="square" lIns="73152" rIns="73152"/>
+                    <a:bodyPr/>
                     <a:lstStyle/>
                     <a:p>
                       <a:pPr>
@@ -14644,7 +15035,7 @@
                 </a:tc>
                 <a:tc>
                   <a:txBody>
-                    <a:bodyPr wrap="square" lIns="73152" rIns="73152"/>
+                    <a:bodyPr/>
                     <a:lstStyle/>
                     <a:p>
                       <a:pPr>
@@ -14666,11 +15057,16 @@
                     </a:solidFill>
                   </a:tcPr>
                 </a:tc>
+                <a:extLst>
+                  <a:ext uri="{0D108BD9-81ED-4DB2-BD59-A6C34878D82A}">
+                    <a16:rowId xmlns:a16="http://schemas.microsoft.com/office/drawing/2014/main" val="10005"/>
+                  </a:ext>
+                </a:extLst>
               </a:tr>
               <a:tr h="633552">
                 <a:tc>
                   <a:txBody>
-                    <a:bodyPr wrap="square" lIns="73152" rIns="73152"/>
+                    <a:bodyPr/>
                     <a:lstStyle/>
                     <a:p>
                       <a:pPr>
@@ -14698,7 +15094,7 @@
                 </a:tc>
                 <a:tc>
                   <a:txBody>
-                    <a:bodyPr wrap="square" lIns="73152" rIns="73152"/>
+                    <a:bodyPr/>
                     <a:lstStyle/>
                     <a:p>
                       <a:pPr>
@@ -14722,7 +15118,7 @@
                 </a:tc>
                 <a:tc>
                   <a:txBody>
-                    <a:bodyPr wrap="square" lIns="73152" rIns="73152"/>
+                    <a:bodyPr/>
                     <a:lstStyle/>
                     <a:p>
                       <a:pPr>
@@ -14750,7 +15146,7 @@
                 </a:tc>
                 <a:tc>
                   <a:txBody>
-                    <a:bodyPr wrap="square" lIns="73152" rIns="73152"/>
+                    <a:bodyPr/>
                     <a:lstStyle/>
                     <a:p>
                       <a:pPr>
@@ -14778,7 +15174,7 @@
                 </a:tc>
                 <a:tc>
                   <a:txBody>
-                    <a:bodyPr wrap="square" lIns="73152" rIns="73152"/>
+                    <a:bodyPr/>
                     <a:lstStyle/>
                     <a:p>
                       <a:pPr>
@@ -14800,6 +15196,11 @@
                     </a:solidFill>
                   </a:tcPr>
                 </a:tc>
+                <a:extLst>
+                  <a:ext uri="{0D108BD9-81ED-4DB2-BD59-A6C34878D82A}">
+                    <a16:rowId xmlns:a16="http://schemas.microsoft.com/office/drawing/2014/main" val="10006"/>
+                  </a:ext>
+                </a:extLst>
               </a:tr>
             </a:tbl>
           </a:graphicData>
@@ -14822,7 +15223,7 @@
           <a:noFill/>
         </p:spPr>
         <p:txBody>
-          <a:bodyPr wrap="none" lIns="0" rIns="0" tIns="0" bIns="0">
+          <a:bodyPr wrap="none" lIns="0" tIns="0" rIns="0" bIns="0">
             <a:spAutoFit/>
           </a:bodyPr>
           <a:lstStyle/>
@@ -14858,7 +15259,7 @@
           <a:noFill/>
         </p:spPr>
         <p:txBody>
-          <a:bodyPr wrap="none" lIns="0" rIns="0" tIns="0" bIns="0">
+          <a:bodyPr wrap="none" lIns="0" tIns="0" rIns="0" bIns="0">
             <a:spAutoFit/>
           </a:bodyPr>
           <a:lstStyle/>

</xml_diff>